<commit_message>
Vorbereitung auf Anpassung für 3. Kurs
</commit_message>
<xml_diff>
--- a/src/Infos.pptx
+++ b/src/Infos.pptx
@@ -6,9 +6,11 @@
   </p:sldMasterIdLst>
   <p:sldIdLst>
     <p:sldId id="318" r:id="rId2"/>
-    <p:sldId id="314" r:id="rId3"/>
-    <p:sldId id="315" r:id="rId4"/>
-    <p:sldId id="317" r:id="rId5"/>
+    <p:sldId id="320" r:id="rId3"/>
+    <p:sldId id="321" r:id="rId4"/>
+    <p:sldId id="324" r:id="rId5"/>
+    <p:sldId id="322" r:id="rId6"/>
+    <p:sldId id="323" r:id="rId7"/>
   </p:sldIdLst>
   <p:sldSz cx="12192000" cy="6858000"/>
   <p:notesSz cx="7104063" cy="10234613"/>
@@ -108,21 +110,6 @@
     </a:lvl9pPr>
   </p:defaultTextStyle>
   <p:extLst>
-    <p:ext uri="{521415D9-36F7-43E2-AB2F-B90AF26B5E84}">
-      <p14:sectionLst xmlns:p14="http://schemas.microsoft.com/office/powerpoint/2010/main">
-        <p14:section name="Allgemein" id="{385FA9E0-450F-423E-B235-5384D0AF7780}">
-          <p14:sldIdLst/>
-        </p14:section>
-        <p14:section name="Bedienung" id="{BBAC5551-2E42-4348-B559-83824DAA8B41}">
-          <p14:sldIdLst>
-            <p14:sldId id="318"/>
-            <p14:sldId id="314"/>
-            <p14:sldId id="315"/>
-            <p14:sldId id="317"/>
-          </p14:sldIdLst>
-        </p14:section>
-      </p14:sectionLst>
-    </p:ext>
     <p:ext uri="{EFAFB233-063F-42B5-8137-9DF3F51BA10A}">
       <p15:sldGuideLst xmlns:p15="http://schemas.microsoft.com/office/powerpoint/2012/main"/>
     </p:ext>
@@ -267,7 +254,7 @@
           <a:p>
             <a:fld id="{7F74B683-5B55-47E9-B45C-EB67E1285507}" type="datetimeFigureOut">
               <a:rPr lang="de-DE" smtClean="0"/>
-              <a:t>19.04.2025</a:t>
+              <a:t>26.09.2025</a:t>
             </a:fld>
             <a:endParaRPr lang="de-DE"/>
           </a:p>
@@ -437,7 +424,7 @@
           <a:p>
             <a:fld id="{7F74B683-5B55-47E9-B45C-EB67E1285507}" type="datetimeFigureOut">
               <a:rPr lang="de-DE" smtClean="0"/>
-              <a:t>19.04.2025</a:t>
+              <a:t>26.09.2025</a:t>
             </a:fld>
             <a:endParaRPr lang="de-DE"/>
           </a:p>
@@ -617,7 +604,7 @@
           <a:p>
             <a:fld id="{7F74B683-5B55-47E9-B45C-EB67E1285507}" type="datetimeFigureOut">
               <a:rPr lang="de-DE" smtClean="0"/>
-              <a:t>19.04.2025</a:t>
+              <a:t>26.09.2025</a:t>
             </a:fld>
             <a:endParaRPr lang="de-DE"/>
           </a:p>
@@ -787,7 +774,7 @@
           <a:p>
             <a:fld id="{7F74B683-5B55-47E9-B45C-EB67E1285507}" type="datetimeFigureOut">
               <a:rPr lang="de-DE" smtClean="0"/>
-              <a:t>19.04.2025</a:t>
+              <a:t>26.09.2025</a:t>
             </a:fld>
             <a:endParaRPr lang="de-DE"/>
           </a:p>
@@ -1033,7 +1020,7 @@
           <a:p>
             <a:fld id="{7F74B683-5B55-47E9-B45C-EB67E1285507}" type="datetimeFigureOut">
               <a:rPr lang="de-DE" smtClean="0"/>
-              <a:t>19.04.2025</a:t>
+              <a:t>26.09.2025</a:t>
             </a:fld>
             <a:endParaRPr lang="de-DE"/>
           </a:p>
@@ -1265,7 +1252,7 @@
           <a:p>
             <a:fld id="{7F74B683-5B55-47E9-B45C-EB67E1285507}" type="datetimeFigureOut">
               <a:rPr lang="de-DE" smtClean="0"/>
-              <a:t>19.04.2025</a:t>
+              <a:t>26.09.2025</a:t>
             </a:fld>
             <a:endParaRPr lang="de-DE"/>
           </a:p>
@@ -1632,7 +1619,7 @@
           <a:p>
             <a:fld id="{7F74B683-5B55-47E9-B45C-EB67E1285507}" type="datetimeFigureOut">
               <a:rPr lang="de-DE" smtClean="0"/>
-              <a:t>19.04.2025</a:t>
+              <a:t>26.09.2025</a:t>
             </a:fld>
             <a:endParaRPr lang="de-DE"/>
           </a:p>
@@ -1750,7 +1737,7 @@
           <a:p>
             <a:fld id="{7F74B683-5B55-47E9-B45C-EB67E1285507}" type="datetimeFigureOut">
               <a:rPr lang="de-DE" smtClean="0"/>
-              <a:t>19.04.2025</a:t>
+              <a:t>26.09.2025</a:t>
             </a:fld>
             <a:endParaRPr lang="de-DE"/>
           </a:p>
@@ -1845,7 +1832,7 @@
           <a:p>
             <a:fld id="{7F74B683-5B55-47E9-B45C-EB67E1285507}" type="datetimeFigureOut">
               <a:rPr lang="de-DE" smtClean="0"/>
-              <a:t>19.04.2025</a:t>
+              <a:t>26.09.2025</a:t>
             </a:fld>
             <a:endParaRPr lang="de-DE"/>
           </a:p>
@@ -2122,7 +2109,7 @@
           <a:p>
             <a:fld id="{7F74B683-5B55-47E9-B45C-EB67E1285507}" type="datetimeFigureOut">
               <a:rPr lang="de-DE" smtClean="0"/>
-              <a:t>19.04.2025</a:t>
+              <a:t>26.09.2025</a:t>
             </a:fld>
             <a:endParaRPr lang="de-DE"/>
           </a:p>
@@ -2379,7 +2366,7 @@
           <a:p>
             <a:fld id="{7F74B683-5B55-47E9-B45C-EB67E1285507}" type="datetimeFigureOut">
               <a:rPr lang="de-DE" smtClean="0"/>
-              <a:t>19.04.2025</a:t>
+              <a:t>26.09.2025</a:t>
             </a:fld>
             <a:endParaRPr lang="de-DE"/>
           </a:p>
@@ -2592,7 +2579,7 @@
           <a:p>
             <a:fld id="{7F74B683-5B55-47E9-B45C-EB67E1285507}" type="datetimeFigureOut">
               <a:rPr lang="de-DE" smtClean="0"/>
-              <a:t>19.04.2025</a:t>
+              <a:t>26.09.2025</a:t>
             </a:fld>
             <a:endParaRPr lang="de-DE"/>
           </a:p>
@@ -3043,14 +3030,7 @@
           <a:lstStyle/>
           <a:p>
             <a:r>
-              <a:rPr lang="de-DE" dirty="0">
-                <a:solidFill>
-                  <a:schemeClr val="accent4">
-                    <a:lumMod val="20000"/>
-                    <a:lumOff val="80000"/>
-                  </a:schemeClr>
-                </a:solidFill>
-              </a:rPr>
+              <a:rPr lang="de-DE" dirty="0"/>
               <a:t>Informationen</a:t>
             </a:r>
           </a:p>
@@ -3200,10 +3180,10 @@
       </p:grpSpPr>
       <p:sp>
         <p:nvSpPr>
-          <p:cNvPr id="2" name="Titel 1">
+          <p:cNvPr id="2" name="Title 1">
             <a:extLst>
               <a:ext uri="{FF2B5EF4-FFF2-40B4-BE49-F238E27FC236}">
-                <a16:creationId xmlns:a16="http://schemas.microsoft.com/office/drawing/2014/main" id="{4B71DD04-3BD8-4A71-A4F7-714837989730}"/>
+                <a16:creationId xmlns:a16="http://schemas.microsoft.com/office/drawing/2014/main" id="{40D0B76D-BC5E-4B07-ACC0-A7E2DF6068A9}"/>
               </a:ext>
             </a:extLst>
           </p:cNvPr>
@@ -3220,29 +3200,787 @@
           <a:lstStyle/>
           <a:p>
             <a:r>
-              <a:rPr lang="de-DE"/>
-              <a:t>Eingabe von Symbolen</a:t>
+              <a:rPr kumimoji="0" lang="de-DE" altLang="de-DE" sz="4400" b="0" i="0" u="none" strike="noStrike" cap="none" normalizeH="0" baseline="0" dirty="0">
+                <a:ln>
+                  <a:noFill/>
+                </a:ln>
+                <a:effectLst/>
+                <a:latin typeface="Calibri Light" panose="020F0302020204030204" pitchFamily="34" charset="0"/>
+                <a:ea typeface="Times New Roman" panose="02020603050405020304" pitchFamily="18" charset="0"/>
+                <a:cs typeface="Times New Roman" panose="02020603050405020304" pitchFamily="18" charset="0"/>
+              </a:rPr>
+              <a:t>Kursstart</a:t>
+            </a:r>
+            <a:endParaRPr lang="de-DE" dirty="0"/>
+          </a:p>
+        </p:txBody>
+      </p:sp>
+      <p:sp>
+        <p:nvSpPr>
+          <p:cNvPr id="3" name="Content Placeholder 2">
+            <a:extLst>
+              <a:ext uri="{FF2B5EF4-FFF2-40B4-BE49-F238E27FC236}">
+                <a16:creationId xmlns:a16="http://schemas.microsoft.com/office/drawing/2014/main" id="{DE29B966-6D1E-4B7D-9C37-B4227451FADF}"/>
+              </a:ext>
+            </a:extLst>
+          </p:cNvPr>
+          <p:cNvSpPr>
+            <a:spLocks noGrp="1"/>
+          </p:cNvSpPr>
+          <p:nvPr>
+            <p:ph idx="1"/>
+          </p:nvPr>
+        </p:nvSpPr>
+        <p:spPr/>
+        <p:txBody>
+          <a:bodyPr>
+            <a:normAutofit fontScale="70000" lnSpcReduction="20000"/>
+          </a:bodyPr>
+          <a:lstStyle/>
+          <a:p>
+            <a:pPr marL="0" marR="0" lvl="0" indent="0" algn="l" defTabSz="914400" rtl="0" eaLnBrk="0" fontAlgn="base" latinLnBrk="0" hangingPunct="0">
+              <a:lnSpc>
+                <a:spcPct val="100000"/>
+              </a:lnSpc>
+              <a:spcBef>
+                <a:spcPct val="0"/>
+              </a:spcBef>
+              <a:spcAft>
+                <a:spcPct val="0"/>
+              </a:spcAft>
+              <a:buClrTx/>
+              <a:buSzTx/>
+              <a:buFontTx/>
+              <a:buNone/>
+              <a:tabLst/>
+            </a:pPr>
+            <a:r>
+              <a:rPr kumimoji="0" lang="de-DE" altLang="de-DE" sz="2800" b="0" i="0" u="none" strike="noStrike" cap="none" normalizeH="0" baseline="0" dirty="0">
+                <a:ln>
+                  <a:noFill/>
+                </a:ln>
+                <a:effectLst/>
+                <a:latin typeface="Calibri" panose="020F0502020204030204" pitchFamily="34" charset="0"/>
+                <a:ea typeface="Calibri" panose="020F0502020204030204" pitchFamily="34" charset="0"/>
+                <a:cs typeface="Times New Roman" panose="02020603050405020304" pitchFamily="18" charset="0"/>
+              </a:rPr>
+              <a:t>Hallo!</a:t>
+            </a:r>
+            <a:endParaRPr kumimoji="0" lang="de-DE" altLang="de-DE" sz="800" b="0" i="0" u="none" strike="noStrike" cap="none" normalizeH="0" baseline="0" dirty="0">
+              <a:ln>
+                <a:noFill/>
+              </a:ln>
+              <a:effectLst/>
+            </a:endParaRPr>
+          </a:p>
+          <a:p>
+            <a:pPr eaLnBrk="0" fontAlgn="base" hangingPunct="0">
+              <a:lnSpc>
+                <a:spcPct val="100000"/>
+              </a:lnSpc>
+              <a:spcBef>
+                <a:spcPct val="0"/>
+              </a:spcBef>
+              <a:spcAft>
+                <a:spcPct val="0"/>
+              </a:spcAft>
+            </a:pPr>
+            <a:r>
+              <a:rPr kumimoji="0" lang="de-DE" altLang="de-DE" sz="2800" b="0" i="0" u="none" strike="noStrike" cap="none" normalizeH="0" baseline="0" dirty="0">
+                <a:ln>
+                  <a:noFill/>
+                </a:ln>
+                <a:effectLst/>
+                <a:latin typeface="Calibri" panose="020F0502020204030204" pitchFamily="34" charset="0"/>
+                <a:ea typeface="Calibri" panose="020F0502020204030204" pitchFamily="34" charset="0"/>
+                <a:cs typeface="Times New Roman" panose="02020603050405020304" pitchFamily="18" charset="0"/>
+              </a:rPr>
+              <a:t>Am 22.02. beginnt der Programmierkurs an der Junior Uni.</a:t>
+            </a:r>
+            <a:endParaRPr lang="de-DE" altLang="de-DE" sz="800" dirty="0"/>
+          </a:p>
+          <a:p>
+            <a:pPr eaLnBrk="0" fontAlgn="base" hangingPunct="0">
+              <a:lnSpc>
+                <a:spcPct val="100000"/>
+              </a:lnSpc>
+              <a:spcBef>
+                <a:spcPct val="0"/>
+              </a:spcBef>
+              <a:spcAft>
+                <a:spcPct val="0"/>
+              </a:spcAft>
+            </a:pPr>
+            <a:r>
+              <a:rPr kumimoji="0" lang="de-DE" altLang="de-DE" sz="2800" b="0" i="0" u="none" strike="noStrike" cap="none" normalizeH="0" baseline="0" dirty="0">
+                <a:ln>
+                  <a:noFill/>
+                </a:ln>
+                <a:effectLst/>
+                <a:latin typeface="Calibri" panose="020F0502020204030204" pitchFamily="34" charset="0"/>
+                <a:ea typeface="Calibri" panose="020F0502020204030204" pitchFamily="34" charset="0"/>
+                <a:cs typeface="Times New Roman" panose="02020603050405020304" pitchFamily="18" charset="0"/>
+              </a:rPr>
+              <a:t>Standort: Gesundheitspark Altenessen (ehem. Marienhospital)</a:t>
+            </a:r>
+            <a:br>
+              <a:rPr kumimoji="0" lang="de-DE" altLang="de-DE" sz="2800" b="0" i="0" u="none" strike="noStrike" cap="none" normalizeH="0" baseline="0" dirty="0">
+                <a:ln>
+                  <a:noFill/>
+                </a:ln>
+                <a:effectLst/>
+                <a:latin typeface="Calibri" panose="020F0502020204030204" pitchFamily="34" charset="0"/>
+                <a:ea typeface="Calibri" panose="020F0502020204030204" pitchFamily="34" charset="0"/>
+                <a:cs typeface="Times New Roman" panose="02020603050405020304" pitchFamily="18" charset="0"/>
+              </a:rPr>
+            </a:br>
+            <a:r>
+              <a:rPr kumimoji="0" lang="de-DE" altLang="de-DE" sz="2800" b="0" i="0" u="none" strike="noStrike" cap="none" normalizeH="0" baseline="0" dirty="0">
+                <a:ln>
+                  <a:noFill/>
+                </a:ln>
+                <a:effectLst/>
+                <a:latin typeface="Calibri" panose="020F0502020204030204" pitchFamily="34" charset="0"/>
+                <a:ea typeface="Calibri" panose="020F0502020204030204" pitchFamily="34" charset="0"/>
+                <a:cs typeface="Times New Roman" panose="02020603050405020304" pitchFamily="18" charset="0"/>
+              </a:rPr>
+              <a:t>Hospitalstraße 24</a:t>
+            </a:r>
+            <a:br>
+              <a:rPr kumimoji="0" lang="de-DE" altLang="de-DE" sz="2800" b="0" i="0" u="none" strike="noStrike" cap="none" normalizeH="0" baseline="0" dirty="0">
+                <a:ln>
+                  <a:noFill/>
+                </a:ln>
+                <a:effectLst/>
+                <a:latin typeface="Calibri" panose="020F0502020204030204" pitchFamily="34" charset="0"/>
+                <a:ea typeface="Calibri" panose="020F0502020204030204" pitchFamily="34" charset="0"/>
+                <a:cs typeface="Times New Roman" panose="02020603050405020304" pitchFamily="18" charset="0"/>
+              </a:rPr>
+            </a:br>
+            <a:r>
+              <a:rPr kumimoji="0" lang="de-DE" altLang="de-DE" sz="2800" b="0" i="0" u="none" strike="noStrike" cap="none" normalizeH="0" baseline="0" dirty="0">
+                <a:ln>
+                  <a:noFill/>
+                </a:ln>
+                <a:effectLst/>
+                <a:latin typeface="Calibri" panose="020F0502020204030204" pitchFamily="34" charset="0"/>
+                <a:ea typeface="Calibri" panose="020F0502020204030204" pitchFamily="34" charset="0"/>
+                <a:cs typeface="Times New Roman" panose="02020603050405020304" pitchFamily="18" charset="0"/>
+              </a:rPr>
+              <a:t>45329 Essen</a:t>
+            </a:r>
+            <a:endParaRPr lang="de-DE" altLang="de-DE" sz="800" dirty="0"/>
+          </a:p>
+          <a:p>
+            <a:pPr eaLnBrk="0" fontAlgn="base" hangingPunct="0">
+              <a:lnSpc>
+                <a:spcPct val="100000"/>
+              </a:lnSpc>
+              <a:spcBef>
+                <a:spcPct val="0"/>
+              </a:spcBef>
+              <a:spcAft>
+                <a:spcPct val="0"/>
+              </a:spcAft>
+            </a:pPr>
+            <a:r>
+              <a:rPr kumimoji="0" lang="de-DE" altLang="de-DE" sz="2800" b="0" i="0" u="none" strike="noStrike" cap="none" normalizeH="0" baseline="0" dirty="0">
+                <a:ln>
+                  <a:noFill/>
+                </a:ln>
+                <a:effectLst/>
+                <a:latin typeface="Calibri" panose="020F0502020204030204" pitchFamily="34" charset="0"/>
+                <a:ea typeface="Calibri" panose="020F0502020204030204" pitchFamily="34" charset="0"/>
+                <a:cs typeface="Times New Roman" panose="02020603050405020304" pitchFamily="18" charset="0"/>
+              </a:rPr>
+              <a:t>Es wäre super, wenn du zu allen Terminen kommst, da die Inhalte aufeinander aufbauen.</a:t>
+            </a:r>
+          </a:p>
+          <a:p>
+            <a:pPr eaLnBrk="0" fontAlgn="base" hangingPunct="0">
+              <a:lnSpc>
+                <a:spcPct val="100000"/>
+              </a:lnSpc>
+              <a:spcBef>
+                <a:spcPct val="0"/>
+              </a:spcBef>
+              <a:spcAft>
+                <a:spcPct val="0"/>
+              </a:spcAft>
+            </a:pPr>
+            <a:r>
+              <a:rPr lang="de-DE" altLang="de-DE" dirty="0">
+                <a:latin typeface="Calibri" panose="020F0502020204030204" pitchFamily="34" charset="0"/>
+                <a:ea typeface="Calibri" panose="020F0502020204030204" pitchFamily="34" charset="0"/>
+                <a:cs typeface="Times New Roman" panose="02020603050405020304" pitchFamily="18" charset="0"/>
+              </a:rPr>
+              <a:t>Du bekommst </a:t>
+            </a:r>
+            <a:r>
+              <a:rPr kumimoji="0" lang="de-DE" altLang="de-DE" sz="2800" b="0" i="0" u="none" strike="noStrike" cap="none" normalizeH="0" baseline="0" dirty="0">
+                <a:ln>
+                  <a:noFill/>
+                </a:ln>
+                <a:effectLst/>
+                <a:latin typeface="Calibri" panose="020F0502020204030204" pitchFamily="34" charset="0"/>
+                <a:ea typeface="Calibri" panose="020F0502020204030204" pitchFamily="34" charset="0"/>
+                <a:cs typeface="Times New Roman" panose="02020603050405020304" pitchFamily="18" charset="0"/>
+              </a:rPr>
+              <a:t>für die Dauer des Kurses einen leistungsstarken Laptop zusammen mit einem Netzteil und einer Tasche bereitgestellt, den du für die Entwicklung des Spiels verwendest. Bring dazu bitte den </a:t>
+            </a:r>
+            <a:r>
+              <a:rPr kumimoji="0" lang="de-DE" altLang="de-DE" sz="2800" b="1" i="0" u="none" strike="noStrike" cap="none" normalizeH="0" baseline="0" dirty="0">
+                <a:ln>
+                  <a:noFill/>
+                </a:ln>
+                <a:effectLst/>
+                <a:latin typeface="Calibri" panose="020F0502020204030204" pitchFamily="34" charset="0"/>
+                <a:ea typeface="Calibri" panose="020F0502020204030204" pitchFamily="34" charset="0"/>
+                <a:cs typeface="Times New Roman" panose="02020603050405020304" pitchFamily="18" charset="0"/>
+              </a:rPr>
+              <a:t>Leihvertrag</a:t>
+            </a:r>
+            <a:r>
+              <a:rPr kumimoji="0" lang="de-DE" altLang="de-DE" sz="2800" b="0" i="0" u="none" strike="noStrike" cap="none" normalizeH="0" baseline="0" dirty="0">
+                <a:ln>
+                  <a:noFill/>
+                </a:ln>
+                <a:effectLst/>
+                <a:latin typeface="Calibri" panose="020F0502020204030204" pitchFamily="34" charset="0"/>
+                <a:ea typeface="Calibri" panose="020F0502020204030204" pitchFamily="34" charset="0"/>
+                <a:cs typeface="Times New Roman" panose="02020603050405020304" pitchFamily="18" charset="0"/>
+              </a:rPr>
+              <a:t> zum ersten Kurstermin ausgefüllt und unterschrieben mit.</a:t>
+            </a:r>
+            <a:endParaRPr lang="de-DE" altLang="de-DE" sz="800" dirty="0"/>
+          </a:p>
+          <a:p>
+            <a:pPr eaLnBrk="0" fontAlgn="base" hangingPunct="0">
+              <a:lnSpc>
+                <a:spcPct val="100000"/>
+              </a:lnSpc>
+              <a:spcBef>
+                <a:spcPct val="0"/>
+              </a:spcBef>
+              <a:spcAft>
+                <a:spcPct val="0"/>
+              </a:spcAft>
+            </a:pPr>
+            <a:r>
+              <a:rPr kumimoji="0" lang="de-DE" altLang="de-DE" sz="2800" b="0" i="0" u="none" strike="noStrike" cap="none" normalizeH="0" baseline="0" dirty="0">
+                <a:ln>
+                  <a:noFill/>
+                </a:ln>
+                <a:effectLst/>
+                <a:latin typeface="Calibri" panose="020F0502020204030204" pitchFamily="34" charset="0"/>
+                <a:ea typeface="Calibri" panose="020F0502020204030204" pitchFamily="34" charset="0"/>
+                <a:cs typeface="Times New Roman" panose="02020603050405020304" pitchFamily="18" charset="0"/>
+              </a:rPr>
+              <a:t>Du kannst das Spiel direkt auf einem Android-Handy testen! </a:t>
+            </a:r>
+            <a:br>
+              <a:rPr kumimoji="0" lang="de-DE" altLang="de-DE" sz="2800" b="0" i="0" u="none" strike="noStrike" cap="none" normalizeH="0" baseline="0" dirty="0">
+                <a:ln>
+                  <a:noFill/>
+                </a:ln>
+                <a:effectLst/>
+                <a:latin typeface="Calibri" panose="020F0502020204030204" pitchFamily="34" charset="0"/>
+                <a:ea typeface="Calibri" panose="020F0502020204030204" pitchFamily="34" charset="0"/>
+                <a:cs typeface="Times New Roman" panose="02020603050405020304" pitchFamily="18" charset="0"/>
+              </a:rPr>
+            </a:br>
+            <a:r>
+              <a:rPr kumimoji="0" lang="de-DE" altLang="de-DE" sz="2800" b="0" i="0" u="none" strike="noStrike" cap="none" normalizeH="0" baseline="0" dirty="0">
+                <a:ln>
+                  <a:noFill/>
+                </a:ln>
+                <a:effectLst/>
+                <a:latin typeface="Calibri" panose="020F0502020204030204" pitchFamily="34" charset="0"/>
+                <a:ea typeface="Calibri" panose="020F0502020204030204" pitchFamily="34" charset="0"/>
+                <a:cs typeface="Times New Roman" panose="02020603050405020304" pitchFamily="18" charset="0"/>
+              </a:rPr>
+              <a:t>Nimm dein </a:t>
+            </a:r>
+            <a:r>
+              <a:rPr kumimoji="0" lang="de-DE" altLang="de-DE" sz="2800" b="1" i="0" u="none" strike="noStrike" cap="none" normalizeH="0" baseline="0" dirty="0">
+                <a:ln>
+                  <a:noFill/>
+                </a:ln>
+                <a:effectLst/>
+                <a:latin typeface="Calibri" panose="020F0502020204030204" pitchFamily="34" charset="0"/>
+                <a:ea typeface="Calibri" panose="020F0502020204030204" pitchFamily="34" charset="0"/>
+                <a:cs typeface="Times New Roman" panose="02020603050405020304" pitchFamily="18" charset="0"/>
+              </a:rPr>
+              <a:t>Handy</a:t>
+            </a:r>
+            <a:r>
+              <a:rPr kumimoji="0" lang="de-DE" altLang="de-DE" sz="2800" b="0" i="0" u="none" strike="noStrike" cap="none" normalizeH="0" baseline="0" dirty="0">
+                <a:ln>
+                  <a:noFill/>
+                </a:ln>
+                <a:effectLst/>
+                <a:latin typeface="Calibri" panose="020F0502020204030204" pitchFamily="34" charset="0"/>
+                <a:ea typeface="Calibri" panose="020F0502020204030204" pitchFamily="34" charset="0"/>
+                <a:cs typeface="Times New Roman" panose="02020603050405020304" pitchFamily="18" charset="0"/>
+              </a:rPr>
+              <a:t> zusammen mit einem </a:t>
+            </a:r>
+            <a:r>
+              <a:rPr kumimoji="0" lang="de-DE" altLang="de-DE" sz="2800" b="1" i="0" u="none" strike="noStrike" cap="none" normalizeH="0" baseline="0" dirty="0">
+                <a:ln>
+                  <a:noFill/>
+                </a:ln>
+                <a:effectLst/>
+                <a:latin typeface="Calibri" panose="020F0502020204030204" pitchFamily="34" charset="0"/>
+                <a:ea typeface="Calibri" panose="020F0502020204030204" pitchFamily="34" charset="0"/>
+                <a:cs typeface="Times New Roman" panose="02020603050405020304" pitchFamily="18" charset="0"/>
+              </a:rPr>
+              <a:t>USB-C-Kabel</a:t>
+            </a:r>
+            <a:r>
+              <a:rPr kumimoji="0" lang="de-DE" altLang="de-DE" sz="2800" b="0" i="0" u="none" strike="noStrike" cap="none" normalizeH="0" baseline="0" dirty="0">
+                <a:ln>
+                  <a:noFill/>
+                </a:ln>
+                <a:effectLst/>
+                <a:latin typeface="Calibri" panose="020F0502020204030204" pitchFamily="34" charset="0"/>
+                <a:ea typeface="Calibri" panose="020F0502020204030204" pitchFamily="34" charset="0"/>
+                <a:cs typeface="Times New Roman" panose="02020603050405020304" pitchFamily="18" charset="0"/>
+              </a:rPr>
+              <a:t> mit.</a:t>
+            </a:r>
+            <a:br>
+              <a:rPr kumimoji="0" lang="de-DE" altLang="de-DE" sz="2800" b="0" i="0" u="none" strike="noStrike" cap="none" normalizeH="0" baseline="0" dirty="0">
+                <a:ln>
+                  <a:noFill/>
+                </a:ln>
+                <a:effectLst/>
+                <a:latin typeface="Calibri" panose="020F0502020204030204" pitchFamily="34" charset="0"/>
+                <a:ea typeface="Calibri" panose="020F0502020204030204" pitchFamily="34" charset="0"/>
+                <a:cs typeface="Times New Roman" panose="02020603050405020304" pitchFamily="18" charset="0"/>
+              </a:rPr>
+            </a:br>
+            <a:r>
+              <a:rPr kumimoji="0" lang="de-DE" altLang="de-DE" sz="2800" b="1" i="0" u="none" strike="noStrike" cap="none" normalizeH="0" baseline="0" dirty="0">
+                <a:ln>
+                  <a:noFill/>
+                </a:ln>
+                <a:solidFill>
+                  <a:srgbClr val="F27D82"/>
+                </a:solidFill>
+                <a:effectLst/>
+                <a:latin typeface="Calibri" panose="020F0502020204030204" pitchFamily="34" charset="0"/>
+                <a:ea typeface="Calibri" panose="020F0502020204030204" pitchFamily="34" charset="0"/>
+                <a:cs typeface="Times New Roman" panose="02020603050405020304" pitchFamily="18" charset="0"/>
+              </a:rPr>
+              <a:t>Auf dem Handy darf kein Family Link installiert sein.</a:t>
+            </a:r>
+            <a:br>
+              <a:rPr kumimoji="0" lang="de-DE" altLang="de-DE" sz="2800" b="0" i="0" u="none" strike="noStrike" cap="none" normalizeH="0" baseline="0" dirty="0">
+                <a:ln>
+                  <a:noFill/>
+                </a:ln>
+                <a:effectLst/>
+                <a:latin typeface="Calibri" panose="020F0502020204030204" pitchFamily="34" charset="0"/>
+                <a:ea typeface="Calibri" panose="020F0502020204030204" pitchFamily="34" charset="0"/>
+                <a:cs typeface="Times New Roman" panose="02020603050405020304" pitchFamily="18" charset="0"/>
+              </a:rPr>
+            </a:br>
+            <a:r>
+              <a:rPr kumimoji="0" lang="de-DE" altLang="de-DE" sz="2800" b="0" i="0" u="none" strike="noStrike" cap="none" normalizeH="0" baseline="0" dirty="0">
+                <a:ln>
+                  <a:noFill/>
+                </a:ln>
+                <a:effectLst/>
+                <a:latin typeface="Calibri" panose="020F0502020204030204" pitchFamily="34" charset="0"/>
+                <a:ea typeface="Calibri" panose="020F0502020204030204" pitchFamily="34" charset="0"/>
+                <a:cs typeface="Times New Roman" panose="02020603050405020304" pitchFamily="18" charset="0"/>
+              </a:rPr>
+              <a:t>Wir können das Spiel aufgrund der Restriktionen des Apple-Ökosystems leider nicht auf iOS installieren.</a:t>
+            </a:r>
+            <a:endParaRPr kumimoji="0" lang="de-DE" altLang="de-DE" sz="800" b="0" i="0" u="none" strike="noStrike" cap="none" normalizeH="0" baseline="0" dirty="0">
+              <a:ln>
+                <a:noFill/>
+              </a:ln>
+              <a:effectLst/>
+            </a:endParaRPr>
+          </a:p>
+          <a:p>
+            <a:pPr marL="0" marR="0" lvl="0" indent="0" algn="l" defTabSz="914400" rtl="0" eaLnBrk="0" fontAlgn="base" latinLnBrk="0" hangingPunct="0">
+              <a:lnSpc>
+                <a:spcPct val="100000"/>
+              </a:lnSpc>
+              <a:spcBef>
+                <a:spcPct val="0"/>
+              </a:spcBef>
+              <a:spcAft>
+                <a:spcPct val="0"/>
+              </a:spcAft>
+              <a:buClrTx/>
+              <a:buSzTx/>
+              <a:buFontTx/>
+              <a:buNone/>
+              <a:tabLst/>
+            </a:pPr>
+            <a:r>
+              <a:rPr kumimoji="0" lang="de-DE" altLang="de-DE" sz="2800" b="0" i="0" u="none" strike="noStrike" cap="none" normalizeH="0" baseline="0" dirty="0">
+                <a:ln>
+                  <a:noFill/>
+                </a:ln>
+                <a:effectLst/>
+                <a:latin typeface="Calibri" panose="020F0502020204030204" pitchFamily="34" charset="0"/>
+                <a:ea typeface="Calibri" panose="020F0502020204030204" pitchFamily="34" charset="0"/>
+                <a:cs typeface="Times New Roman" panose="02020603050405020304" pitchFamily="18" charset="0"/>
+              </a:rPr>
+              <a:t>Wir freuen uns auf euch!</a:t>
+            </a:r>
+            <a:endParaRPr kumimoji="0" lang="de-DE" altLang="de-DE" sz="800" b="0" i="0" u="none" strike="noStrike" cap="none" normalizeH="0" baseline="0" dirty="0">
+              <a:ln>
+                <a:noFill/>
+              </a:ln>
+              <a:effectLst/>
+            </a:endParaRPr>
+          </a:p>
+          <a:p>
+            <a:pPr marL="0" marR="0" lvl="0" indent="0" algn="l" defTabSz="914400" rtl="0" eaLnBrk="0" fontAlgn="base" latinLnBrk="0" hangingPunct="0">
+              <a:lnSpc>
+                <a:spcPct val="100000"/>
+              </a:lnSpc>
+              <a:spcBef>
+                <a:spcPct val="0"/>
+              </a:spcBef>
+              <a:spcAft>
+                <a:spcPct val="0"/>
+              </a:spcAft>
+              <a:buClrTx/>
+              <a:buSzTx/>
+              <a:buFontTx/>
+              <a:buNone/>
+              <a:tabLst/>
+            </a:pPr>
+            <a:r>
+              <a:rPr kumimoji="0" lang="de-DE" altLang="de-DE" sz="2800" b="0" i="0" u="none" strike="noStrike" cap="none" normalizeH="0" baseline="0" dirty="0">
+                <a:ln>
+                  <a:noFill/>
+                </a:ln>
+                <a:effectLst/>
+                <a:latin typeface="Calibri" panose="020F0502020204030204" pitchFamily="34" charset="0"/>
+                <a:ea typeface="Calibri" panose="020F0502020204030204" pitchFamily="34" charset="0"/>
+                <a:cs typeface="Times New Roman" panose="02020603050405020304" pitchFamily="18" charset="0"/>
+              </a:rPr>
+              <a:t>Lion und Lasse</a:t>
+            </a:r>
+            <a:endParaRPr kumimoji="0" lang="de-DE" altLang="de-DE" sz="4000" b="0" i="0" u="none" strike="noStrike" cap="none" normalizeH="0" baseline="0" dirty="0">
+              <a:ln>
+                <a:noFill/>
+              </a:ln>
+              <a:effectLst/>
+              <a:latin typeface="Arial" panose="020B0604020202020204" pitchFamily="34" charset="0"/>
+            </a:endParaRPr>
+          </a:p>
+        </p:txBody>
+      </p:sp>
+      <p:pic>
+        <p:nvPicPr>
+          <p:cNvPr id="4" name="Grafik 2">
+            <a:extLst>
+              <a:ext uri="{FF2B5EF4-FFF2-40B4-BE49-F238E27FC236}">
+                <a16:creationId xmlns:a16="http://schemas.microsoft.com/office/drawing/2014/main" id="{4E13E666-F493-4FA2-8C13-DB671F879985}"/>
+              </a:ext>
+            </a:extLst>
+          </p:cNvPr>
+          <p:cNvPicPr>
+            <a:picLocks noChangeAspect="1" noChangeArrowheads="1"/>
+          </p:cNvPicPr>
+          <p:nvPr/>
+        </p:nvPicPr>
+        <p:blipFill>
+          <a:blip r:embed="rId2">
+            <a:extLst>
+              <a:ext uri="{28A0092B-C50C-407E-A947-70E740481C1C}">
+                <a14:useLocalDpi xmlns:a14="http://schemas.microsoft.com/office/drawing/2010/main" val="0"/>
+              </a:ext>
+            </a:extLst>
+          </a:blip>
+          <a:srcRect l="23828" t="26936" b="33696"/>
+          <a:stretch>
+            <a:fillRect/>
+          </a:stretch>
+        </p:blipFill>
+        <p:spPr bwMode="auto">
+          <a:xfrm>
+            <a:off x="10545762" y="3672151"/>
+            <a:ext cx="1646238" cy="850900"/>
+          </a:xfrm>
+          <a:prstGeom prst="rect">
+            <a:avLst/>
+          </a:prstGeom>
+          <a:noFill/>
+          <a:extLst>
+            <a:ext uri="{909E8E84-426E-40DD-AFC4-6F175D3DCCD1}">
+              <a14:hiddenFill xmlns:a14="http://schemas.microsoft.com/office/drawing/2010/main">
+                <a:solidFill>
+                  <a:srgbClr val="FFFFFF"/>
+                </a:solidFill>
+              </a14:hiddenFill>
+            </a:ext>
+          </a:extLst>
+        </p:spPr>
+      </p:pic>
+    </p:spTree>
+    <p:extLst>
+      <p:ext uri="{BB962C8B-B14F-4D97-AF65-F5344CB8AC3E}">
+        <p14:creationId xmlns:p14="http://schemas.microsoft.com/office/powerpoint/2010/main" val="233118332"/>
+      </p:ext>
+    </p:extLst>
+  </p:cSld>
+  <p:clrMapOvr>
+    <a:masterClrMapping/>
+  </p:clrMapOvr>
+</p:sld>
+</file>
+
+<file path=ppt/slides/slide3.xml><?xml version="1.0" encoding="utf-8"?>
+<p:sld xmlns:a="http://schemas.openxmlformats.org/drawingml/2006/main" xmlns:r="http://schemas.openxmlformats.org/officeDocument/2006/relationships" xmlns:p="http://schemas.openxmlformats.org/presentationml/2006/main">
+  <p:cSld>
+    <p:spTree>
+      <p:nvGrpSpPr>
+        <p:cNvPr id="1" name=""/>
+        <p:cNvGrpSpPr/>
+        <p:nvPr/>
+      </p:nvGrpSpPr>
+      <p:grpSpPr>
+        <a:xfrm>
+          <a:off x="0" y="0"/>
+          <a:ext cx="0" cy="0"/>
+          <a:chOff x="0" y="0"/>
+          <a:chExt cx="0" cy="0"/>
+        </a:xfrm>
+      </p:grpSpPr>
+      <p:sp>
+        <p:nvSpPr>
+          <p:cNvPr id="2" name="Title 1">
+            <a:extLst>
+              <a:ext uri="{FF2B5EF4-FFF2-40B4-BE49-F238E27FC236}">
+                <a16:creationId xmlns:a16="http://schemas.microsoft.com/office/drawing/2014/main" id="{2263D464-E8A6-4F16-B231-80688280C1CE}"/>
+              </a:ext>
+            </a:extLst>
+          </p:cNvPr>
+          <p:cNvSpPr>
+            <a:spLocks noGrp="1"/>
+          </p:cNvSpPr>
+          <p:nvPr>
+            <p:ph type="title"/>
+          </p:nvPr>
+        </p:nvSpPr>
+        <p:spPr/>
+        <p:txBody>
+          <a:bodyPr/>
+          <a:lstStyle/>
+          <a:p>
+            <a:r>
+              <a:rPr lang="de-DE" dirty="0"/>
+              <a:t>Family Link Restriktionen umgehen</a:t>
+            </a:r>
+          </a:p>
+        </p:txBody>
+      </p:sp>
+      <p:sp>
+        <p:nvSpPr>
+          <p:cNvPr id="3" name="Content Placeholder 2">
+            <a:extLst>
+              <a:ext uri="{FF2B5EF4-FFF2-40B4-BE49-F238E27FC236}">
+                <a16:creationId xmlns:a16="http://schemas.microsoft.com/office/drawing/2014/main" id="{3686047F-D17B-45AD-9B67-5524A12FF697}"/>
+              </a:ext>
+            </a:extLst>
+          </p:cNvPr>
+          <p:cNvSpPr>
+            <a:spLocks noGrp="1"/>
+          </p:cNvSpPr>
+          <p:nvPr>
+            <p:ph idx="1"/>
+          </p:nvPr>
+        </p:nvSpPr>
+        <p:spPr/>
+        <p:txBody>
+          <a:bodyPr/>
+          <a:lstStyle/>
+          <a:p>
+            <a:pPr marL="0" indent="0">
+              <a:buNone/>
+            </a:pPr>
+            <a:r>
+              <a:rPr lang="de-DE" dirty="0"/>
+              <a:t>…</a:t>
+            </a:r>
+          </a:p>
+        </p:txBody>
+      </p:sp>
+    </p:spTree>
+    <p:extLst>
+      <p:ext uri="{BB962C8B-B14F-4D97-AF65-F5344CB8AC3E}">
+        <p14:creationId xmlns:p14="http://schemas.microsoft.com/office/powerpoint/2010/main" val="789373505"/>
+      </p:ext>
+    </p:extLst>
+  </p:cSld>
+  <p:clrMapOvr>
+    <a:masterClrMapping/>
+  </p:clrMapOvr>
+</p:sld>
+</file>
+
+<file path=ppt/slides/slide4.xml><?xml version="1.0" encoding="utf-8"?>
+<p:sld xmlns:a="http://schemas.openxmlformats.org/drawingml/2006/main" xmlns:r="http://schemas.openxmlformats.org/officeDocument/2006/relationships" xmlns:p="http://schemas.openxmlformats.org/presentationml/2006/main">
+  <p:cSld>
+    <p:spTree>
+      <p:nvGrpSpPr>
+        <p:cNvPr id="1" name=""/>
+        <p:cNvGrpSpPr/>
+        <p:nvPr/>
+      </p:nvGrpSpPr>
+      <p:grpSpPr>
+        <a:xfrm>
+          <a:off x="0" y="0"/>
+          <a:ext cx="0" cy="0"/>
+          <a:chOff x="0" y="0"/>
+          <a:chExt cx="0" cy="0"/>
+        </a:xfrm>
+      </p:grpSpPr>
+      <p:sp>
+        <p:nvSpPr>
+          <p:cNvPr id="2" name="Title 1">
+            <a:extLst>
+              <a:ext uri="{FF2B5EF4-FFF2-40B4-BE49-F238E27FC236}">
+                <a16:creationId xmlns:a16="http://schemas.microsoft.com/office/drawing/2014/main" id="{48FDF813-EE93-425A-B044-6AAE2FADF940}"/>
+              </a:ext>
+            </a:extLst>
+          </p:cNvPr>
+          <p:cNvSpPr>
+            <a:spLocks noGrp="1"/>
+          </p:cNvSpPr>
+          <p:nvPr>
+            <p:ph type="title"/>
+          </p:nvPr>
+        </p:nvSpPr>
+        <p:spPr/>
+        <p:txBody>
+          <a:bodyPr/>
+          <a:lstStyle/>
+          <a:p>
+            <a:r>
+              <a:rPr lang="de-DE" dirty="0"/>
+              <a:t>Informationen recherchieren</a:t>
+            </a:r>
+          </a:p>
+        </p:txBody>
+      </p:sp>
+      <p:sp>
+        <p:nvSpPr>
+          <p:cNvPr id="3" name="Content Placeholder 2">
+            <a:extLst>
+              <a:ext uri="{FF2B5EF4-FFF2-40B4-BE49-F238E27FC236}">
+                <a16:creationId xmlns:a16="http://schemas.microsoft.com/office/drawing/2014/main" id="{02ACB7ED-8D0E-4ED2-A0C2-4FA896016D31}"/>
+              </a:ext>
+            </a:extLst>
+          </p:cNvPr>
+          <p:cNvSpPr>
+            <a:spLocks noGrp="1"/>
+          </p:cNvSpPr>
+          <p:nvPr>
+            <p:ph idx="1"/>
+          </p:nvPr>
+        </p:nvSpPr>
+        <p:spPr/>
+        <p:txBody>
+          <a:bodyPr/>
+          <a:lstStyle/>
+          <a:p>
+            <a:endParaRPr lang="de-DE"/>
+          </a:p>
+        </p:txBody>
+      </p:sp>
+    </p:spTree>
+    <p:extLst>
+      <p:ext uri="{BB962C8B-B14F-4D97-AF65-F5344CB8AC3E}">
+        <p14:creationId xmlns:p14="http://schemas.microsoft.com/office/powerpoint/2010/main" val="1095441688"/>
+      </p:ext>
+    </p:extLst>
+  </p:cSld>
+  <p:clrMapOvr>
+    <a:masterClrMapping/>
+  </p:clrMapOvr>
+</p:sld>
+</file>
+
+<file path=ppt/slides/slide5.xml><?xml version="1.0" encoding="utf-8"?>
+<p:sld xmlns:a="http://schemas.openxmlformats.org/drawingml/2006/main" xmlns:r="http://schemas.openxmlformats.org/officeDocument/2006/relationships" xmlns:p="http://schemas.openxmlformats.org/presentationml/2006/main">
+  <p:cSld>
+    <p:spTree>
+      <p:nvGrpSpPr>
+        <p:cNvPr id="1" name=""/>
+        <p:cNvGrpSpPr/>
+        <p:nvPr/>
+      </p:nvGrpSpPr>
+      <p:grpSpPr>
+        <a:xfrm>
+          <a:off x="0" y="0"/>
+          <a:ext cx="0" cy="0"/>
+          <a:chOff x="0" y="0"/>
+          <a:chExt cx="0" cy="0"/>
+        </a:xfrm>
+      </p:grpSpPr>
+      <p:sp>
+        <p:nvSpPr>
+          <p:cNvPr id="2" name="Title 1">
+            <a:extLst>
+              <a:ext uri="{FF2B5EF4-FFF2-40B4-BE49-F238E27FC236}">
+                <a16:creationId xmlns:a16="http://schemas.microsoft.com/office/drawing/2014/main" id="{742E89BC-A7E5-4160-B7AC-C37B5B5B627A}"/>
+              </a:ext>
+            </a:extLst>
+          </p:cNvPr>
+          <p:cNvSpPr>
+            <a:spLocks noGrp="1"/>
+          </p:cNvSpPr>
+          <p:nvPr>
+            <p:ph type="title"/>
+          </p:nvPr>
+        </p:nvSpPr>
+        <p:spPr/>
+        <p:txBody>
+          <a:bodyPr/>
+          <a:lstStyle/>
+          <a:p>
+            <a:r>
+              <a:rPr lang="de-DE" dirty="0"/>
+              <a:t>Ablauf Sommersemester 2025</a:t>
             </a:r>
           </a:p>
         </p:txBody>
       </p:sp>
       <p:graphicFrame>
         <p:nvGraphicFramePr>
-          <p:cNvPr id="4" name="Tabelle 7">
+          <p:cNvPr id="4" name="Table 4">
             <a:extLst>
               <a:ext uri="{FF2B5EF4-FFF2-40B4-BE49-F238E27FC236}">
-                <a16:creationId xmlns:a16="http://schemas.microsoft.com/office/drawing/2014/main" id="{36A5935D-4966-45D8-A2DD-102E2AD40272}"/>
+                <a16:creationId xmlns:a16="http://schemas.microsoft.com/office/drawing/2014/main" id="{0F764F4F-A0F2-4F8D-B731-509381F16F8A}"/>
               </a:ext>
             </a:extLst>
           </p:cNvPr>
           <p:cNvGraphicFramePr>
             <a:graphicFrameLocks noGrp="1"/>
           </p:cNvGraphicFramePr>
-          <p:nvPr/>
+          <p:nvPr>
+            <p:ph idx="1"/>
+            <p:extLst>
+              <p:ext uri="{D42A27DB-BD31-4B8C-83A1-F6EECF244321}">
+                <p14:modId xmlns:p14="http://schemas.microsoft.com/office/powerpoint/2010/main" val="3442310689"/>
+              </p:ext>
+            </p:extLst>
+          </p:nvPr>
         </p:nvGraphicFramePr>
         <p:xfrm>
-          <a:off x="838200" y="1690687"/>
-          <a:ext cx="10515600" cy="4802193"/>
+          <a:off x="838200" y="1825625"/>
+          <a:ext cx="10515596" cy="4079240"/>
         </p:xfrm>
         <a:graphic>
           <a:graphicData uri="http://schemas.openxmlformats.org/drawingml/2006/table">
@@ -3251,42 +3989,46 @@
                 <a:tableStyleId>{5C22544A-7EE6-4342-B048-85BDC9FD1C3A}</a:tableStyleId>
               </a:tblPr>
               <a:tblGrid>
-                <a:gridCol w="3505200">
+                <a:gridCol w="427892">
                   <a:extLst>
                     <a:ext uri="{9D8B030D-6E8A-4147-A177-3AD203B41FA5}">
-                      <a16:colId xmlns:a16="http://schemas.microsoft.com/office/drawing/2014/main" val="2317810761"/>
+                      <a16:colId xmlns:a16="http://schemas.microsoft.com/office/drawing/2014/main" val="3675322223"/>
                     </a:ext>
                   </a:extLst>
                 </a:gridCol>
-                <a:gridCol w="5466080">
+                <a:gridCol w="1572272">
                   <a:extLst>
                     <a:ext uri="{9D8B030D-6E8A-4147-A177-3AD203B41FA5}">
-                      <a16:colId xmlns:a16="http://schemas.microsoft.com/office/drawing/2014/main" val="3760803087"/>
+                      <a16:colId xmlns:a16="http://schemas.microsoft.com/office/drawing/2014/main" val="829809223"/>
                     </a:ext>
                   </a:extLst>
                 </a:gridCol>
-                <a:gridCol w="1544320">
+                <a:gridCol w="1046802">
                   <a:extLst>
                     <a:ext uri="{9D8B030D-6E8A-4147-A177-3AD203B41FA5}">
-                      <a16:colId xmlns:a16="http://schemas.microsoft.com/office/drawing/2014/main" val="2063619127"/>
+                      <a16:colId xmlns:a16="http://schemas.microsoft.com/office/drawing/2014/main" val="3562242639"/>
+                    </a:ext>
+                  </a:extLst>
+                </a:gridCol>
+                <a:gridCol w="7468630">
+                  <a:extLst>
+                    <a:ext uri="{9D8B030D-6E8A-4147-A177-3AD203B41FA5}">
+                      <a16:colId xmlns:a16="http://schemas.microsoft.com/office/drawing/2014/main" val="162909940"/>
                     </a:ext>
                   </a:extLst>
                 </a:gridCol>
               </a:tblGrid>
-              <a:tr h="436563">
+              <a:tr h="370840">
                 <a:tc>
                   <a:txBody>
                     <a:bodyPr/>
                     <a:lstStyle/>
                     <a:p>
-                      <a:r>
-                        <a:rPr lang="de-DE" u="none">
-                          <a:solidFill>
-                            <a:schemeClr val="tx1"/>
-                          </a:solidFill>
-                        </a:rPr>
-                        <a:t>Name</a:t>
-                      </a:r>
+                      <a:endParaRPr lang="de-DE" dirty="0">
+                        <a:solidFill>
+                          <a:schemeClr val="tx1"/>
+                        </a:solidFill>
+                      </a:endParaRPr>
                     </a:p>
                   </a:txBody>
                   <a:tcPr>
@@ -3319,12 +4061,12 @@
                     <a:lstStyle/>
                     <a:p>
                       <a:r>
-                        <a:rPr lang="de-DE" u="none">
+                        <a:rPr lang="de-DE" dirty="0">
                           <a:solidFill>
                             <a:schemeClr val="tx1"/>
                           </a:solidFill>
                         </a:rPr>
-                        <a:t>Kombination</a:t>
+                        <a:t>Datum</a:t>
                       </a:r>
                     </a:p>
                   </a:txBody>
@@ -3358,12 +4100,12 @@
                     <a:lstStyle/>
                     <a:p>
                       <a:r>
-                        <a:rPr lang="de-DE" u="none">
+                        <a:rPr lang="de-DE" dirty="0">
                           <a:solidFill>
                             <a:schemeClr val="tx1"/>
                           </a:solidFill>
                         </a:rPr>
-                        <a:t>Symbole</a:t>
+                        <a:t>Uhrzeit</a:t>
                       </a:r>
                     </a:p>
                   </a:txBody>
@@ -3378,52 +4120,6 @@
                       <a:noFill/>
                     </a:lnT>
                     <a:lnB w="38100" cmpd="sng">
-                      <a:noFill/>
-                    </a:lnB>
-                    <a:lnTlToBr w="12700" cmpd="sng">
-                      <a:noFill/>
-                      <a:prstDash val="solid"/>
-                    </a:lnTlToBr>
-                    <a:lnBlToTr w="12700" cmpd="sng">
-                      <a:noFill/>
-                      <a:prstDash val="solid"/>
-                    </a:lnBlToTr>
-                    <a:noFill/>
-                  </a:tcPr>
-                </a:tc>
-                <a:extLst>
-                  <a:ext uri="{0D108BD9-81ED-4DB2-BD59-A6C34878D82A}">
-                    <a16:rowId xmlns:a16="http://schemas.microsoft.com/office/drawing/2014/main" val="2371139332"/>
-                  </a:ext>
-                </a:extLst>
-              </a:tr>
-              <a:tr h="436563">
-                <a:tc>
-                  <a:txBody>
-                    <a:bodyPr/>
-                    <a:lstStyle/>
-                    <a:p>
-                      <a:r>
-                        <a:rPr lang="de-DE" u="none">
-                          <a:solidFill>
-                            <a:schemeClr val="tx1"/>
-                          </a:solidFill>
-                        </a:rPr>
-                        <a:t>Semikolon, Doppelpunkt</a:t>
-                      </a:r>
-                    </a:p>
-                  </a:txBody>
-                  <a:tcPr>
-                    <a:lnL w="12700" cmpd="sng">
-                      <a:noFill/>
-                    </a:lnL>
-                    <a:lnR w="12700" cmpd="sng">
-                      <a:noFill/>
-                    </a:lnR>
-                    <a:lnT w="38100" cmpd="sng">
-                      <a:noFill/>
-                    </a:lnT>
-                    <a:lnB w="12700" cmpd="sng">
                       <a:noFill/>
                     </a:lnB>
                     <a:lnTlToBr w="12700" cmpd="sng">
@@ -3443,12 +4139,59 @@
                     <a:lstStyle/>
                     <a:p>
                       <a:r>
-                        <a:rPr lang="de-DE" u="none">
+                        <a:rPr lang="de-DE" dirty="0">
                           <a:solidFill>
                             <a:schemeClr val="tx1"/>
                           </a:solidFill>
                         </a:rPr>
-                        <a:t>Shift + Komma (,) / Punkt (.)</a:t>
+                        <a:t>Inhalt</a:t>
+                      </a:r>
+                    </a:p>
+                  </a:txBody>
+                  <a:tcPr>
+                    <a:lnL w="12700" cmpd="sng">
+                      <a:noFill/>
+                    </a:lnL>
+                    <a:lnR w="12700" cmpd="sng">
+                      <a:noFill/>
+                    </a:lnR>
+                    <a:lnT w="12700" cmpd="sng">
+                      <a:noFill/>
+                    </a:lnT>
+                    <a:lnB w="38100" cmpd="sng">
+                      <a:noFill/>
+                    </a:lnB>
+                    <a:lnTlToBr w="12700" cmpd="sng">
+                      <a:noFill/>
+                      <a:prstDash val="solid"/>
+                    </a:lnTlToBr>
+                    <a:lnBlToTr w="12700" cmpd="sng">
+                      <a:noFill/>
+                      <a:prstDash val="solid"/>
+                    </a:lnBlToTr>
+                    <a:noFill/>
+                  </a:tcPr>
+                </a:tc>
+                <a:extLst>
+                  <a:ext uri="{0D108BD9-81ED-4DB2-BD59-A6C34878D82A}">
+                    <a16:rowId xmlns:a16="http://schemas.microsoft.com/office/drawing/2014/main" val="3313997392"/>
+                  </a:ext>
+                </a:extLst>
+              </a:tr>
+              <a:tr h="370840">
+                <a:tc>
+                  <a:txBody>
+                    <a:bodyPr/>
+                    <a:lstStyle/>
+                    <a:p>
+                      <a:pPr algn="r"/>
+                      <a:r>
+                        <a:rPr lang="de-DE" dirty="0">
+                          <a:solidFill>
+                            <a:schemeClr val="tx1"/>
+                          </a:solidFill>
+                        </a:rPr>
+                        <a:t>1</a:t>
                       </a:r>
                     </a:p>
                   </a:txBody>
@@ -3482,12 +4225,12 @@
                     <a:lstStyle/>
                     <a:p>
                       <a:r>
-                        <a:rPr lang="de-DE" u="none">
+                        <a:rPr lang="de-DE" dirty="0">
                           <a:solidFill>
                             <a:schemeClr val="tx1"/>
                           </a:solidFill>
                         </a:rPr>
-                        <a:t>; :</a:t>
+                        <a:t>Freitag, 20.2.</a:t>
                       </a:r>
                     </a:p>
                   </a:txBody>
@@ -3499,52 +4242,6 @@
                       <a:noFill/>
                     </a:lnR>
                     <a:lnT w="38100" cmpd="sng">
-                      <a:noFill/>
-                    </a:lnT>
-                    <a:lnB w="12700" cmpd="sng">
-                      <a:noFill/>
-                    </a:lnB>
-                    <a:lnTlToBr w="12700" cmpd="sng">
-                      <a:noFill/>
-                      <a:prstDash val="solid"/>
-                    </a:lnTlToBr>
-                    <a:lnBlToTr w="12700" cmpd="sng">
-                      <a:noFill/>
-                      <a:prstDash val="solid"/>
-                    </a:lnBlToTr>
-                    <a:noFill/>
-                  </a:tcPr>
-                </a:tc>
-                <a:extLst>
-                  <a:ext uri="{0D108BD9-81ED-4DB2-BD59-A6C34878D82A}">
-                    <a16:rowId xmlns:a16="http://schemas.microsoft.com/office/drawing/2014/main" val="1137631992"/>
-                  </a:ext>
-                </a:extLst>
-              </a:tr>
-              <a:tr h="436563">
-                <a:tc>
-                  <a:txBody>
-                    <a:bodyPr/>
-                    <a:lstStyle/>
-                    <a:p>
-                      <a:r>
-                        <a:rPr lang="de-DE" u="none">
-                          <a:solidFill>
-                            <a:schemeClr val="tx1"/>
-                          </a:solidFill>
-                        </a:rPr>
-                        <a:t>Anführungsstrich(e)</a:t>
-                      </a:r>
-                    </a:p>
-                  </a:txBody>
-                  <a:tcPr>
-                    <a:lnL w="12700" cmpd="sng">
-                      <a:noFill/>
-                    </a:lnL>
-                    <a:lnR w="12700" cmpd="sng">
-                      <a:noFill/>
-                    </a:lnR>
-                    <a:lnT w="12700" cmpd="sng">
                       <a:noFill/>
                     </a:lnT>
                     <a:lnB w="12700" cmpd="sng">
@@ -3567,12 +4264,12 @@
                     <a:lstStyle/>
                     <a:p>
                       <a:r>
-                        <a:rPr lang="de-DE" u="none">
+                        <a:rPr lang="de-DE" dirty="0">
                           <a:solidFill>
                             <a:schemeClr val="tx1"/>
                           </a:solidFill>
                         </a:rPr>
-                        <a:t>Shift + Hashtag (#) / 2</a:t>
+                        <a:t>17 – 20 ?</a:t>
                       </a:r>
                     </a:p>
                   </a:txBody>
@@ -3583,7 +4280,7 @@
                     <a:lnR w="12700" cmpd="sng">
                       <a:noFill/>
                     </a:lnR>
-                    <a:lnT w="12700" cmpd="sng">
+                    <a:lnT w="38100" cmpd="sng">
                       <a:noFill/>
                     </a:lnT>
                     <a:lnB w="12700" cmpd="sng">
@@ -3606,12 +4303,12 @@
                     <a:lstStyle/>
                     <a:p>
                       <a:r>
-                        <a:rPr lang="de-DE" u="none">
+                        <a:rPr lang="de-DE" dirty="0">
                           <a:solidFill>
                             <a:schemeClr val="tx1"/>
                           </a:solidFill>
                         </a:rPr>
-                        <a:t>' "</a:t>
+                        <a:t>IDE, Befehle, Variablen, Datentypen und Operationen</a:t>
                       </a:r>
                     </a:p>
                   </a:txBody>
@@ -3622,7 +4319,7 @@
                     <a:lnR w="12700" cmpd="sng">
                       <a:noFill/>
                     </a:lnR>
-                    <a:lnT w="12700" cmpd="sng">
+                    <a:lnT w="38100" cmpd="sng">
                       <a:noFill/>
                     </a:lnT>
                     <a:lnB w="12700" cmpd="sng">
@@ -3641,23 +4338,24 @@
                 </a:tc>
                 <a:extLst>
                   <a:ext uri="{0D108BD9-81ED-4DB2-BD59-A6C34878D82A}">
-                    <a16:rowId xmlns:a16="http://schemas.microsoft.com/office/drawing/2014/main" val="735349028"/>
+                    <a16:rowId xmlns:a16="http://schemas.microsoft.com/office/drawing/2014/main" val="2519105199"/>
                   </a:ext>
                 </a:extLst>
               </a:tr>
-              <a:tr h="436563">
+              <a:tr h="370840">
                 <a:tc>
                   <a:txBody>
                     <a:bodyPr/>
                     <a:lstStyle/>
                     <a:p>
+                      <a:pPr algn="r"/>
                       <a:r>
-                        <a:rPr lang="de-DE" u="none">
+                        <a:rPr lang="de-DE" dirty="0">
                           <a:solidFill>
                             <a:schemeClr val="tx1"/>
                           </a:solidFill>
                         </a:rPr>
-                        <a:t>Runde Klammern</a:t>
+                        <a:t>2</a:t>
                       </a:r>
                     </a:p>
                   </a:txBody>
@@ -3691,152 +4389,12 @@
                     <a:lstStyle/>
                     <a:p>
                       <a:r>
-                        <a:rPr lang="de-DE" u="none">
+                        <a:rPr lang="de-DE" dirty="0">
                           <a:solidFill>
                             <a:schemeClr val="tx1"/>
                           </a:solidFill>
                         </a:rPr>
-                        <a:t>Shift + 8/9</a:t>
-                      </a:r>
-                    </a:p>
-                  </a:txBody>
-                  <a:tcPr>
-                    <a:lnL w="12700" cmpd="sng">
-                      <a:noFill/>
-                    </a:lnL>
-                    <a:lnR w="12700" cmpd="sng">
-                      <a:noFill/>
-                    </a:lnR>
-                    <a:lnT w="12700" cmpd="sng">
-                      <a:noFill/>
-                    </a:lnT>
-                    <a:lnB w="12700" cmpd="sng">
-                      <a:noFill/>
-                    </a:lnB>
-                    <a:lnTlToBr w="12700" cmpd="sng">
-                      <a:noFill/>
-                      <a:prstDash val="solid"/>
-                    </a:lnTlToBr>
-                    <a:lnBlToTr w="12700" cmpd="sng">
-                      <a:noFill/>
-                      <a:prstDash val="solid"/>
-                    </a:lnBlToTr>
-                    <a:noFill/>
-                  </a:tcPr>
-                </a:tc>
-                <a:tc>
-                  <a:txBody>
-                    <a:bodyPr/>
-                    <a:lstStyle/>
-                    <a:p>
-                      <a:r>
-                        <a:rPr lang="de-DE" u="none">
-                          <a:solidFill>
-                            <a:schemeClr val="tx1"/>
-                          </a:solidFill>
-                        </a:rPr>
-                        <a:t>()</a:t>
-                      </a:r>
-                    </a:p>
-                  </a:txBody>
-                  <a:tcPr>
-                    <a:lnL w="12700" cmpd="sng">
-                      <a:noFill/>
-                    </a:lnL>
-                    <a:lnR w="12700" cmpd="sng">
-                      <a:noFill/>
-                    </a:lnR>
-                    <a:lnT w="12700" cmpd="sng">
-                      <a:noFill/>
-                    </a:lnT>
-                    <a:lnB w="12700" cmpd="sng">
-                      <a:noFill/>
-                    </a:lnB>
-                    <a:lnTlToBr w="12700" cmpd="sng">
-                      <a:noFill/>
-                      <a:prstDash val="solid"/>
-                    </a:lnTlToBr>
-                    <a:lnBlToTr w="12700" cmpd="sng">
-                      <a:noFill/>
-                      <a:prstDash val="solid"/>
-                    </a:lnBlToTr>
-                    <a:noFill/>
-                  </a:tcPr>
-                </a:tc>
-                <a:extLst>
-                  <a:ext uri="{0D108BD9-81ED-4DB2-BD59-A6C34878D82A}">
-                    <a16:rowId xmlns:a16="http://schemas.microsoft.com/office/drawing/2014/main" val="1753339480"/>
-                  </a:ext>
-                </a:extLst>
-              </a:tr>
-              <a:tr h="436563">
-                <a:tc>
-                  <a:txBody>
-                    <a:bodyPr/>
-                    <a:lstStyle/>
-                    <a:p>
-                      <a:r>
-                        <a:rPr lang="de-DE" u="none">
-                          <a:solidFill>
-                            <a:schemeClr val="tx1"/>
-                          </a:solidFill>
-                        </a:rPr>
-                        <a:t>Eckige Klammern</a:t>
-                      </a:r>
-                    </a:p>
-                  </a:txBody>
-                  <a:tcPr>
-                    <a:lnL w="12700" cmpd="sng">
-                      <a:noFill/>
-                    </a:lnL>
-                    <a:lnR w="12700" cmpd="sng">
-                      <a:noFill/>
-                    </a:lnR>
-                    <a:lnT w="12700" cmpd="sng">
-                      <a:noFill/>
-                    </a:lnT>
-                    <a:lnB w="12700" cmpd="sng">
-                      <a:noFill/>
-                    </a:lnB>
-                    <a:lnTlToBr w="12700" cmpd="sng">
-                      <a:noFill/>
-                      <a:prstDash val="solid"/>
-                    </a:lnTlToBr>
-                    <a:lnBlToTr w="12700" cmpd="sng">
-                      <a:noFill/>
-                      <a:prstDash val="solid"/>
-                    </a:lnBlToTr>
-                    <a:noFill/>
-                  </a:tcPr>
-                </a:tc>
-                <a:tc>
-                  <a:txBody>
-                    <a:bodyPr/>
-                    <a:lstStyle/>
-                    <a:p>
-                      <a:r>
-                        <a:rPr lang="de-DE" u="none">
-                          <a:solidFill>
-                            <a:schemeClr val="tx1"/>
-                          </a:solidFill>
-                        </a:rPr>
-                        <a:t>Alt </a:t>
-                      </a:r>
-                      <a:r>
-                        <a:rPr lang="de-DE" u="none" err="1">
-                          <a:solidFill>
-                            <a:schemeClr val="tx1"/>
-                          </a:solidFill>
-                        </a:rPr>
-                        <a:t>Gr</a:t>
-                      </a:r>
-                      <a:r>
-                        <a:rPr lang="de-DE" u="none">
-                          <a:solidFill>
-                            <a:schemeClr val="tx1"/>
-                          </a:solidFill>
-                        </a:rPr>
-                        <a:t> + 8/9</a:t>
+                        <a:t>Samstag, 21.2.</a:t>
                       </a:r>
                     </a:p>
                   </a:txBody>
@@ -3887,58 +4445,12 @@
                         <a:defRPr/>
                       </a:pPr>
                       <a:r>
-                        <a:rPr lang="de-DE" u="none">
+                        <a:rPr lang="de-DE" dirty="0">
                           <a:solidFill>
                             <a:schemeClr val="tx1"/>
                           </a:solidFill>
                         </a:rPr>
-                        <a:t>[]</a:t>
-                      </a:r>
-                    </a:p>
-                  </a:txBody>
-                  <a:tcPr>
-                    <a:lnL w="12700" cmpd="sng">
-                      <a:noFill/>
-                    </a:lnL>
-                    <a:lnR w="12700" cmpd="sng">
-                      <a:noFill/>
-                    </a:lnR>
-                    <a:lnT w="12700" cmpd="sng">
-                      <a:noFill/>
-                    </a:lnT>
-                    <a:lnB w="12700" cmpd="sng">
-                      <a:noFill/>
-                    </a:lnB>
-                    <a:lnTlToBr w="12700" cmpd="sng">
-                      <a:noFill/>
-                      <a:prstDash val="solid"/>
-                    </a:lnTlToBr>
-                    <a:lnBlToTr w="12700" cmpd="sng">
-                      <a:noFill/>
-                      <a:prstDash val="solid"/>
-                    </a:lnBlToTr>
-                    <a:noFill/>
-                  </a:tcPr>
-                </a:tc>
-                <a:extLst>
-                  <a:ext uri="{0D108BD9-81ED-4DB2-BD59-A6C34878D82A}">
-                    <a16:rowId xmlns:a16="http://schemas.microsoft.com/office/drawing/2014/main" val="4070795586"/>
-                  </a:ext>
-                </a:extLst>
-              </a:tr>
-              <a:tr h="436563">
-                <a:tc>
-                  <a:txBody>
-                    <a:bodyPr/>
-                    <a:lstStyle/>
-                    <a:p>
-                      <a:r>
-                        <a:rPr lang="de-DE" u="none">
-                          <a:solidFill>
-                            <a:schemeClr val="tx1"/>
-                          </a:solidFill>
-                        </a:rPr>
-                        <a:t>Geschweifte Klammern</a:t>
+                        <a:t>10 – 14</a:t>
                       </a:r>
                     </a:p>
                   </a:txBody>
@@ -3972,28 +4484,115 @@
                     <a:lstStyle/>
                     <a:p>
                       <a:r>
-                        <a:rPr lang="de-DE" u="none">
+                        <a:rPr lang="de-DE" dirty="0">
                           <a:solidFill>
                             <a:schemeClr val="tx1"/>
                           </a:solidFill>
                         </a:rPr>
-                        <a:t>Alt </a:t>
+                        <a:t>Mengen und Abbildungen, Klassen und Methoden, Kontrollfluss</a:t>
                       </a:r>
+                    </a:p>
+                  </a:txBody>
+                  <a:tcPr>
+                    <a:lnL w="12700" cmpd="sng">
+                      <a:noFill/>
+                    </a:lnL>
+                    <a:lnR w="12700" cmpd="sng">
+                      <a:noFill/>
+                    </a:lnR>
+                    <a:lnT w="12700" cmpd="sng">
+                      <a:noFill/>
+                    </a:lnT>
+                    <a:lnB w="12700" cmpd="sng">
+                      <a:noFill/>
+                    </a:lnB>
+                    <a:lnTlToBr w="12700" cmpd="sng">
+                      <a:noFill/>
+                      <a:prstDash val="solid"/>
+                    </a:lnTlToBr>
+                    <a:lnBlToTr w="12700" cmpd="sng">
+                      <a:noFill/>
+                      <a:prstDash val="solid"/>
+                    </a:lnBlToTr>
+                    <a:noFill/>
+                  </a:tcPr>
+                </a:tc>
+                <a:extLst>
+                  <a:ext uri="{0D108BD9-81ED-4DB2-BD59-A6C34878D82A}">
+                    <a16:rowId xmlns:a16="http://schemas.microsoft.com/office/drawing/2014/main" val="2427232611"/>
+                  </a:ext>
+                </a:extLst>
+              </a:tr>
+              <a:tr h="370840">
+                <a:tc>
+                  <a:txBody>
+                    <a:bodyPr/>
+                    <a:lstStyle/>
+                    <a:p>
+                      <a:pPr algn="r"/>
                       <a:r>
-                        <a:rPr lang="de-DE" u="none" err="1">
+                        <a:rPr lang="de-DE" dirty="0">
                           <a:solidFill>
                             <a:schemeClr val="tx1"/>
                           </a:solidFill>
                         </a:rPr>
-                        <a:t>Gr</a:t>
+                        <a:t>3</a:t>
                       </a:r>
+                    </a:p>
+                  </a:txBody>
+                  <a:tcPr>
+                    <a:lnL w="12700" cmpd="sng">
+                      <a:noFill/>
+                    </a:lnL>
+                    <a:lnR w="12700" cmpd="sng">
+                      <a:noFill/>
+                    </a:lnR>
+                    <a:lnT w="12700" cmpd="sng">
+                      <a:noFill/>
+                    </a:lnT>
+                    <a:lnB w="12700" cmpd="sng">
+                      <a:noFill/>
+                    </a:lnB>
+                    <a:lnTlToBr w="12700" cmpd="sng">
+                      <a:noFill/>
+                      <a:prstDash val="solid"/>
+                    </a:lnTlToBr>
+                    <a:lnBlToTr w="12700" cmpd="sng">
+                      <a:noFill/>
+                      <a:prstDash val="solid"/>
+                    </a:lnBlToTr>
+                    <a:noFill/>
+                  </a:tcPr>
+                </a:tc>
+                <a:tc>
+                  <a:txBody>
+                    <a:bodyPr/>
+                    <a:lstStyle/>
+                    <a:p>
+                      <a:pPr marL="0" marR="0" lvl="0" indent="0" algn="l" defTabSz="914400" rtl="0" eaLnBrk="1" fontAlgn="auto" latinLnBrk="0" hangingPunct="1">
+                        <a:lnSpc>
+                          <a:spcPct val="100000"/>
+                        </a:lnSpc>
+                        <a:spcBef>
+                          <a:spcPts val="0"/>
+                        </a:spcBef>
+                        <a:spcAft>
+                          <a:spcPts val="0"/>
+                        </a:spcAft>
+                        <a:buClrTx/>
+                        <a:buSzTx/>
+                        <a:buFontTx/>
+                        <a:buNone/>
+                        <a:tabLst/>
+                        <a:defRPr/>
+                      </a:pPr>
                       <a:r>
-                        <a:rPr lang="de-DE" u="none">
+                        <a:rPr lang="de-DE" dirty="0">
                           <a:solidFill>
                             <a:schemeClr val="tx1"/>
                           </a:solidFill>
                         </a:rPr>
-                        <a:t> + 7/0</a:t>
+                        <a:t>Freitag, 27.2.</a:t>
                       </a:r>
                     </a:p>
                   </a:txBody>
@@ -4027,58 +4626,12 @@
                     <a:lstStyle/>
                     <a:p>
                       <a:r>
-                        <a:rPr lang="de-DE" u="none">
+                        <a:rPr lang="de-DE" dirty="0">
                           <a:solidFill>
                             <a:schemeClr val="tx1"/>
                           </a:solidFill>
                         </a:rPr>
-                        <a:t>{}</a:t>
-                      </a:r>
-                    </a:p>
-                  </a:txBody>
-                  <a:tcPr>
-                    <a:lnL w="12700" cmpd="sng">
-                      <a:noFill/>
-                    </a:lnL>
-                    <a:lnR w="12700" cmpd="sng">
-                      <a:noFill/>
-                    </a:lnR>
-                    <a:lnT w="12700" cmpd="sng">
-                      <a:noFill/>
-                    </a:lnT>
-                    <a:lnB w="12700" cmpd="sng">
-                      <a:noFill/>
-                    </a:lnB>
-                    <a:lnTlToBr w="12700" cmpd="sng">
-                      <a:noFill/>
-                      <a:prstDash val="solid"/>
-                    </a:lnTlToBr>
-                    <a:lnBlToTr w="12700" cmpd="sng">
-                      <a:noFill/>
-                      <a:prstDash val="solid"/>
-                    </a:lnBlToTr>
-                    <a:noFill/>
-                  </a:tcPr>
-                </a:tc>
-                <a:extLst>
-                  <a:ext uri="{0D108BD9-81ED-4DB2-BD59-A6C34878D82A}">
-                    <a16:rowId xmlns:a16="http://schemas.microsoft.com/office/drawing/2014/main" val="3524437853"/>
-                  </a:ext>
-                </a:extLst>
-              </a:tr>
-              <a:tr h="436563">
-                <a:tc>
-                  <a:txBody>
-                    <a:bodyPr/>
-                    <a:lstStyle/>
-                    <a:p>
-                      <a:r>
-                        <a:rPr lang="de-DE" u="none">
-                          <a:solidFill>
-                            <a:schemeClr val="tx1"/>
-                          </a:solidFill>
-                        </a:rPr>
-                        <a:t>Ausrufe/Fragezeichen</a:t>
+                        <a:t>17 – 20 ?</a:t>
                       </a:r>
                     </a:p>
                   </a:txBody>
@@ -4112,12 +4665,171 @@
                     <a:lstStyle/>
                     <a:p>
                       <a:r>
-                        <a:rPr lang="de-DE" u="none">
+                        <a:rPr lang="de-DE" dirty="0">
                           <a:solidFill>
                             <a:schemeClr val="tx1"/>
                           </a:solidFill>
                         </a:rPr>
-                        <a:t>Shift + 1/ß</a:t>
+                        <a:t>Induktion und Rekursion, Datenstrukturen und Algorithmen</a:t>
+                      </a:r>
+                    </a:p>
+                  </a:txBody>
+                  <a:tcPr>
+                    <a:lnL w="12700" cmpd="sng">
+                      <a:noFill/>
+                    </a:lnL>
+                    <a:lnR w="12700" cmpd="sng">
+                      <a:noFill/>
+                    </a:lnR>
+                    <a:lnT w="12700" cmpd="sng">
+                      <a:noFill/>
+                    </a:lnT>
+                    <a:lnB w="12700" cmpd="sng">
+                      <a:noFill/>
+                    </a:lnB>
+                    <a:lnTlToBr w="12700" cmpd="sng">
+                      <a:noFill/>
+                      <a:prstDash val="solid"/>
+                    </a:lnTlToBr>
+                    <a:lnBlToTr w="12700" cmpd="sng">
+                      <a:noFill/>
+                      <a:prstDash val="solid"/>
+                    </a:lnBlToTr>
+                    <a:noFill/>
+                  </a:tcPr>
+                </a:tc>
+                <a:extLst>
+                  <a:ext uri="{0D108BD9-81ED-4DB2-BD59-A6C34878D82A}">
+                    <a16:rowId xmlns:a16="http://schemas.microsoft.com/office/drawing/2014/main" val="1580541138"/>
+                  </a:ext>
+                </a:extLst>
+              </a:tr>
+              <a:tr h="370840">
+                <a:tc>
+                  <a:txBody>
+                    <a:bodyPr/>
+                    <a:lstStyle/>
+                    <a:p>
+                      <a:pPr algn="r"/>
+                      <a:r>
+                        <a:rPr lang="de-DE" dirty="0">
+                          <a:solidFill>
+                            <a:schemeClr val="tx1"/>
+                          </a:solidFill>
+                        </a:rPr>
+                        <a:t>4</a:t>
+                      </a:r>
+                    </a:p>
+                  </a:txBody>
+                  <a:tcPr>
+                    <a:lnL w="12700" cmpd="sng">
+                      <a:noFill/>
+                    </a:lnL>
+                    <a:lnR w="12700" cmpd="sng">
+                      <a:noFill/>
+                    </a:lnR>
+                    <a:lnT w="12700" cmpd="sng">
+                      <a:noFill/>
+                    </a:lnT>
+                    <a:lnB w="12700" cmpd="sng">
+                      <a:noFill/>
+                    </a:lnB>
+                    <a:lnTlToBr w="12700" cmpd="sng">
+                      <a:noFill/>
+                      <a:prstDash val="solid"/>
+                    </a:lnTlToBr>
+                    <a:lnBlToTr w="12700" cmpd="sng">
+                      <a:noFill/>
+                      <a:prstDash val="solid"/>
+                    </a:lnBlToTr>
+                    <a:noFill/>
+                  </a:tcPr>
+                </a:tc>
+                <a:tc>
+                  <a:txBody>
+                    <a:bodyPr/>
+                    <a:lstStyle/>
+                    <a:p>
+                      <a:pPr marL="0" marR="0" lvl="0" indent="0" algn="l" defTabSz="914400" rtl="0" eaLnBrk="1" fontAlgn="auto" latinLnBrk="0" hangingPunct="1">
+                        <a:lnSpc>
+                          <a:spcPct val="100000"/>
+                        </a:lnSpc>
+                        <a:spcBef>
+                          <a:spcPts val="0"/>
+                        </a:spcBef>
+                        <a:spcAft>
+                          <a:spcPts val="0"/>
+                        </a:spcAft>
+                        <a:buClrTx/>
+                        <a:buSzTx/>
+                        <a:buFontTx/>
+                        <a:buNone/>
+                        <a:tabLst/>
+                        <a:defRPr/>
+                      </a:pPr>
+                      <a:r>
+                        <a:rPr lang="de-DE" dirty="0">
+                          <a:solidFill>
+                            <a:schemeClr val="tx1"/>
+                          </a:solidFill>
+                        </a:rPr>
+                        <a:t>Samstag, 28.2.</a:t>
+                      </a:r>
+                    </a:p>
+                  </a:txBody>
+                  <a:tcPr>
+                    <a:lnL w="12700" cmpd="sng">
+                      <a:noFill/>
+                    </a:lnL>
+                    <a:lnR w="12700" cmpd="sng">
+                      <a:noFill/>
+                    </a:lnR>
+                    <a:lnT w="12700" cmpd="sng">
+                      <a:noFill/>
+                    </a:lnT>
+                    <a:lnB w="12700" cmpd="sng">
+                      <a:noFill/>
+                    </a:lnB>
+                    <a:lnTlToBr w="12700" cmpd="sng">
+                      <a:noFill/>
+                      <a:prstDash val="solid"/>
+                    </a:lnTlToBr>
+                    <a:lnBlToTr w="12700" cmpd="sng">
+                      <a:noFill/>
+                      <a:prstDash val="solid"/>
+                    </a:lnBlToTr>
+                    <a:noFill/>
+                  </a:tcPr>
+                </a:tc>
+                <a:tc>
+                  <a:txBody>
+                    <a:bodyPr/>
+                    <a:lstStyle/>
+                    <a:p>
+                      <a:pPr marL="0" marR="0" lvl="0" indent="0" algn="l" defTabSz="914400" rtl="0" eaLnBrk="1" fontAlgn="auto" latinLnBrk="0" hangingPunct="1">
+                        <a:lnSpc>
+                          <a:spcPct val="100000"/>
+                        </a:lnSpc>
+                        <a:spcBef>
+                          <a:spcPts val="0"/>
+                        </a:spcBef>
+                        <a:spcAft>
+                          <a:spcPts val="0"/>
+                        </a:spcAft>
+                        <a:buClrTx/>
+                        <a:buSzTx/>
+                        <a:buFontTx/>
+                        <a:buNone/>
+                        <a:tabLst/>
+                        <a:defRPr/>
+                      </a:pPr>
+                      <a:r>
+                        <a:rPr lang="de-DE" dirty="0">
+                          <a:solidFill>
+                            <a:schemeClr val="tx1"/>
+                          </a:solidFill>
+                        </a:rPr>
+                        <a:t>10 – 14</a:t>
                       </a:r>
                     </a:p>
                   </a:txBody>
@@ -4151,12 +4863,28 @@
                     <a:lstStyle/>
                     <a:p>
                       <a:r>
-                        <a:rPr lang="de-DE" u="none">
+                        <a:rPr lang="de-DE" dirty="0">
                           <a:solidFill>
                             <a:schemeClr val="tx1"/>
                           </a:solidFill>
                         </a:rPr>
-                        <a:t>! ?</a:t>
+                        <a:t>Paradigmen, </a:t>
+                      </a:r>
+                      <a:r>
+                        <a:rPr lang="de-DE" dirty="0" err="1">
+                          <a:solidFill>
+                            <a:schemeClr val="tx1"/>
+                          </a:solidFill>
+                        </a:rPr>
+                        <a:t>Generics</a:t>
+                      </a:r>
+                      <a:r>
+                        <a:rPr lang="de-DE" dirty="0">
+                          <a:solidFill>
+                            <a:schemeClr val="tx1"/>
+                          </a:solidFill>
+                        </a:rPr>
+                        <a:t>, Modellierung</a:t>
                       </a:r>
                     </a:p>
                   </a:txBody>
@@ -4186,23 +4914,80 @@
                 </a:tc>
                 <a:extLst>
                   <a:ext uri="{0D108BD9-81ED-4DB2-BD59-A6C34878D82A}">
-                    <a16:rowId xmlns:a16="http://schemas.microsoft.com/office/drawing/2014/main" val="2223904026"/>
+                    <a16:rowId xmlns:a16="http://schemas.microsoft.com/office/drawing/2014/main" val="913507237"/>
                   </a:ext>
                 </a:extLst>
               </a:tr>
-              <a:tr h="436563">
+              <a:tr h="370840">
                 <a:tc>
                   <a:txBody>
                     <a:bodyPr/>
                     <a:lstStyle/>
                     <a:p>
+                      <a:pPr algn="r"/>
                       <a:r>
-                        <a:rPr lang="de-DE" u="none">
+                        <a:rPr lang="de-DE" dirty="0">
                           <a:solidFill>
                             <a:schemeClr val="tx1"/>
                           </a:solidFill>
                         </a:rPr>
-                        <a:t>Und, Gleich</a:t>
+                        <a:t>5</a:t>
+                      </a:r>
+                    </a:p>
+                  </a:txBody>
+                  <a:tcPr>
+                    <a:lnL w="12700" cmpd="sng">
+                      <a:noFill/>
+                    </a:lnL>
+                    <a:lnR w="12700" cmpd="sng">
+                      <a:noFill/>
+                    </a:lnR>
+                    <a:lnT w="12700" cmpd="sng">
+                      <a:noFill/>
+                    </a:lnT>
+                    <a:lnB w="12700" cmpd="sng">
+                      <a:noFill/>
+                    </a:lnB>
+                    <a:lnTlToBr w="12700" cmpd="sng">
+                      <a:noFill/>
+                      <a:prstDash val="solid"/>
+                    </a:lnTlToBr>
+                    <a:lnBlToTr w="12700" cmpd="sng">
+                      <a:noFill/>
+                      <a:prstDash val="solid"/>
+                    </a:lnBlToTr>
+                    <a:noFill/>
+                  </a:tcPr>
+                </a:tc>
+                <a:tc>
+                  <a:txBody>
+                    <a:bodyPr/>
+                    <a:lstStyle/>
+                    <a:p>
+                      <a:pPr marL="0" marR="0" lvl="0" indent="0" algn="l" defTabSz="914400" rtl="0" eaLnBrk="1" fontAlgn="auto" latinLnBrk="0" hangingPunct="1">
+                        <a:lnSpc>
+                          <a:spcPct val="100000"/>
+                        </a:lnSpc>
+                        <a:spcBef>
+                          <a:spcPts val="0"/>
+                        </a:spcBef>
+                        <a:spcAft>
+                          <a:spcPts val="0"/>
+                        </a:spcAft>
+                        <a:buClrTx/>
+                        <a:buSzTx/>
+                        <a:buFontTx/>
+                        <a:buNone/>
+                        <a:tabLst/>
+                        <a:defRPr/>
+                      </a:pPr>
+                      <a:r>
+                        <a:rPr lang="de-DE" dirty="0">
+                          <a:solidFill>
+                            <a:schemeClr val="tx1"/>
+                          </a:solidFill>
+                        </a:rPr>
+                        <a:t>Freitag, 6.3.</a:t>
                       </a:r>
                     </a:p>
                   </a:txBody>
@@ -4236,12 +5021,12 @@
                     <a:lstStyle/>
                     <a:p>
                       <a:r>
-                        <a:rPr lang="de-DE" u="none">
+                        <a:rPr lang="de-DE" dirty="0">
                           <a:solidFill>
                             <a:schemeClr val="tx1"/>
                           </a:solidFill>
                         </a:rPr>
-                        <a:t>Shift + 6/0</a:t>
+                        <a:t>17 – 20 ?</a:t>
                       </a:r>
                     </a:p>
                   </a:txBody>
@@ -4275,12 +5060,12 @@
                     <a:lstStyle/>
                     <a:p>
                       <a:r>
-                        <a:rPr lang="de-DE" u="none">
+                        <a:rPr lang="de-DE" dirty="0">
                           <a:solidFill>
                             <a:schemeClr val="tx1"/>
                           </a:solidFill>
                         </a:rPr>
-                        <a:t>&amp; =</a:t>
+                        <a:t>Koordinatensysteme, Vektorrechnung, Eingabe/Ausgabe, Rendering (alles 2D)</a:t>
                       </a:r>
                     </a:p>
                   </a:txBody>
@@ -4310,23 +5095,136 @@
                 </a:tc>
                 <a:extLst>
                   <a:ext uri="{0D108BD9-81ED-4DB2-BD59-A6C34878D82A}">
-                    <a16:rowId xmlns:a16="http://schemas.microsoft.com/office/drawing/2014/main" val="2046807540"/>
+                    <a16:rowId xmlns:a16="http://schemas.microsoft.com/office/drawing/2014/main" val="3430108571"/>
                   </a:ext>
                 </a:extLst>
               </a:tr>
-              <a:tr h="436563">
+              <a:tr h="370840">
                 <a:tc>
                   <a:txBody>
                     <a:bodyPr/>
                     <a:lstStyle/>
                     <a:p>
+                      <a:pPr algn="r"/>
                       <a:r>
-                        <a:rPr lang="de-DE" u="none">
+                        <a:rPr lang="de-DE" dirty="0">
                           <a:solidFill>
                             <a:schemeClr val="tx1"/>
                           </a:solidFill>
                         </a:rPr>
-                        <a:t>Senkrechter Strich</a:t>
+                        <a:t>6</a:t>
+                      </a:r>
+                    </a:p>
+                  </a:txBody>
+                  <a:tcPr>
+                    <a:lnL w="12700" cmpd="sng">
+                      <a:noFill/>
+                    </a:lnL>
+                    <a:lnR w="12700" cmpd="sng">
+                      <a:noFill/>
+                    </a:lnR>
+                    <a:lnT w="12700" cmpd="sng">
+                      <a:noFill/>
+                    </a:lnT>
+                    <a:lnB w="12700" cmpd="sng">
+                      <a:noFill/>
+                    </a:lnB>
+                    <a:lnTlToBr w="12700" cmpd="sng">
+                      <a:noFill/>
+                      <a:prstDash val="solid"/>
+                    </a:lnTlToBr>
+                    <a:lnBlToTr w="12700" cmpd="sng">
+                      <a:noFill/>
+                      <a:prstDash val="solid"/>
+                    </a:lnBlToTr>
+                    <a:noFill/>
+                  </a:tcPr>
+                </a:tc>
+                <a:tc>
+                  <a:txBody>
+                    <a:bodyPr/>
+                    <a:lstStyle/>
+                    <a:p>
+                      <a:pPr marL="0" marR="0" lvl="0" indent="0" algn="l" defTabSz="914400" rtl="0" eaLnBrk="1" fontAlgn="auto" latinLnBrk="0" hangingPunct="1">
+                        <a:lnSpc>
+                          <a:spcPct val="100000"/>
+                        </a:lnSpc>
+                        <a:spcBef>
+                          <a:spcPts val="0"/>
+                        </a:spcBef>
+                        <a:spcAft>
+                          <a:spcPts val="0"/>
+                        </a:spcAft>
+                        <a:buClrTx/>
+                        <a:buSzTx/>
+                        <a:buFontTx/>
+                        <a:buNone/>
+                        <a:tabLst/>
+                        <a:defRPr/>
+                      </a:pPr>
+                      <a:r>
+                        <a:rPr lang="de-DE" dirty="0">
+                          <a:solidFill>
+                            <a:schemeClr val="tx1"/>
+                          </a:solidFill>
+                        </a:rPr>
+                        <a:t>Samstag, 7.3.</a:t>
+                      </a:r>
+                    </a:p>
+                  </a:txBody>
+                  <a:tcPr>
+                    <a:lnL w="12700" cmpd="sng">
+                      <a:noFill/>
+                    </a:lnL>
+                    <a:lnR w="12700" cmpd="sng">
+                      <a:noFill/>
+                    </a:lnR>
+                    <a:lnT w="12700" cmpd="sng">
+                      <a:noFill/>
+                    </a:lnT>
+                    <a:lnB w="12700" cmpd="sng">
+                      <a:noFill/>
+                    </a:lnB>
+                    <a:lnTlToBr w="12700" cmpd="sng">
+                      <a:noFill/>
+                      <a:prstDash val="solid"/>
+                    </a:lnTlToBr>
+                    <a:lnBlToTr w="12700" cmpd="sng">
+                      <a:noFill/>
+                      <a:prstDash val="solid"/>
+                    </a:lnBlToTr>
+                    <a:noFill/>
+                  </a:tcPr>
+                </a:tc>
+                <a:tc>
+                  <a:txBody>
+                    <a:bodyPr/>
+                    <a:lstStyle/>
+                    <a:p>
+                      <a:pPr marL="0" marR="0" lvl="0" indent="0" algn="l" defTabSz="914400" rtl="0" eaLnBrk="1" fontAlgn="auto" latinLnBrk="0" hangingPunct="1">
+                        <a:lnSpc>
+                          <a:spcPct val="100000"/>
+                        </a:lnSpc>
+                        <a:spcBef>
+                          <a:spcPts val="0"/>
+                        </a:spcBef>
+                        <a:spcAft>
+                          <a:spcPts val="0"/>
+                        </a:spcAft>
+                        <a:buClrTx/>
+                        <a:buSzTx/>
+                        <a:buFontTx/>
+                        <a:buNone/>
+                        <a:tabLst/>
+                        <a:defRPr/>
+                      </a:pPr>
+                      <a:r>
+                        <a:rPr lang="de-DE" dirty="0">
+                          <a:solidFill>
+                            <a:schemeClr val="tx1"/>
+                          </a:solidFill>
+                        </a:rPr>
+                        <a:t>10 – 14</a:t>
                       </a:r>
                     </a:p>
                   </a:txBody>
@@ -4360,28 +5258,115 @@
                     <a:lstStyle/>
                     <a:p>
                       <a:r>
-                        <a:rPr lang="de-DE" u="none">
+                        <a:rPr lang="de-DE" dirty="0">
                           <a:solidFill>
                             <a:schemeClr val="tx1"/>
                           </a:solidFill>
                         </a:rPr>
-                        <a:t>Alt </a:t>
+                        <a:t>Implementation eines erweiterbaren Open World Spiels</a:t>
                       </a:r>
+                    </a:p>
+                  </a:txBody>
+                  <a:tcPr>
+                    <a:lnL w="12700" cmpd="sng">
+                      <a:noFill/>
+                    </a:lnL>
+                    <a:lnR w="12700" cmpd="sng">
+                      <a:noFill/>
+                    </a:lnR>
+                    <a:lnT w="12700" cmpd="sng">
+                      <a:noFill/>
+                    </a:lnT>
+                    <a:lnB w="12700" cmpd="sng">
+                      <a:noFill/>
+                    </a:lnB>
+                    <a:lnTlToBr w="12700" cmpd="sng">
+                      <a:noFill/>
+                      <a:prstDash val="solid"/>
+                    </a:lnTlToBr>
+                    <a:lnBlToTr w="12700" cmpd="sng">
+                      <a:noFill/>
+                      <a:prstDash val="solid"/>
+                    </a:lnBlToTr>
+                    <a:noFill/>
+                  </a:tcPr>
+                </a:tc>
+                <a:extLst>
+                  <a:ext uri="{0D108BD9-81ED-4DB2-BD59-A6C34878D82A}">
+                    <a16:rowId xmlns:a16="http://schemas.microsoft.com/office/drawing/2014/main" val="624401219"/>
+                  </a:ext>
+                </a:extLst>
+              </a:tr>
+              <a:tr h="370840">
+                <a:tc>
+                  <a:txBody>
+                    <a:bodyPr/>
+                    <a:lstStyle/>
+                    <a:p>
+                      <a:pPr algn="r"/>
                       <a:r>
-                        <a:rPr lang="de-DE" u="none" err="1">
+                        <a:rPr lang="de-DE" dirty="0">
                           <a:solidFill>
                             <a:schemeClr val="tx1"/>
                           </a:solidFill>
                         </a:rPr>
-                        <a:t>Gr</a:t>
+                        <a:t>7</a:t>
                       </a:r>
+                    </a:p>
+                  </a:txBody>
+                  <a:tcPr>
+                    <a:lnL w="12700" cmpd="sng">
+                      <a:noFill/>
+                    </a:lnL>
+                    <a:lnR w="12700" cmpd="sng">
+                      <a:noFill/>
+                    </a:lnR>
+                    <a:lnT w="12700" cmpd="sng">
+                      <a:noFill/>
+                    </a:lnT>
+                    <a:lnB w="12700" cmpd="sng">
+                      <a:noFill/>
+                    </a:lnB>
+                    <a:lnTlToBr w="12700" cmpd="sng">
+                      <a:noFill/>
+                      <a:prstDash val="solid"/>
+                    </a:lnTlToBr>
+                    <a:lnBlToTr w="12700" cmpd="sng">
+                      <a:noFill/>
+                      <a:prstDash val="solid"/>
+                    </a:lnBlToTr>
+                    <a:noFill/>
+                  </a:tcPr>
+                </a:tc>
+                <a:tc>
+                  <a:txBody>
+                    <a:bodyPr/>
+                    <a:lstStyle/>
+                    <a:p>
+                      <a:pPr marL="0" marR="0" lvl="0" indent="0" algn="l" defTabSz="914400" rtl="0" eaLnBrk="1" fontAlgn="auto" latinLnBrk="0" hangingPunct="1">
+                        <a:lnSpc>
+                          <a:spcPct val="100000"/>
+                        </a:lnSpc>
+                        <a:spcBef>
+                          <a:spcPts val="0"/>
+                        </a:spcBef>
+                        <a:spcAft>
+                          <a:spcPts val="0"/>
+                        </a:spcAft>
+                        <a:buClrTx/>
+                        <a:buSzTx/>
+                        <a:buFontTx/>
+                        <a:buNone/>
+                        <a:tabLst/>
+                        <a:defRPr/>
+                      </a:pPr>
                       <a:r>
-                        <a:rPr lang="de-DE" u="none">
+                        <a:rPr lang="de-DE" dirty="0">
                           <a:solidFill>
                             <a:schemeClr val="tx1"/>
                           </a:solidFill>
                         </a:rPr>
-                        <a:t> + &lt;</a:t>
+                        <a:t>Freitag, 13.3.</a:t>
                       </a:r>
                     </a:p>
                   </a:txBody>
@@ -4415,12 +5400,61 @@
                     <a:lstStyle/>
                     <a:p>
                       <a:r>
-                        <a:rPr lang="de-DE" u="none">
+                        <a:rPr lang="de-DE" dirty="0">
                           <a:solidFill>
                             <a:schemeClr val="tx1"/>
                           </a:solidFill>
                         </a:rPr>
-                        <a:t>|</a:t>
+                        <a:t>17 – 20 ?</a:t>
+                      </a:r>
+                    </a:p>
+                  </a:txBody>
+                  <a:tcPr>
+                    <a:lnL w="12700" cmpd="sng">
+                      <a:noFill/>
+                    </a:lnL>
+                    <a:lnR w="12700" cmpd="sng">
+                      <a:noFill/>
+                    </a:lnR>
+                    <a:lnT w="12700" cmpd="sng">
+                      <a:noFill/>
+                    </a:lnT>
+                    <a:lnB w="12700" cmpd="sng">
+                      <a:noFill/>
+                    </a:lnB>
+                    <a:lnTlToBr w="12700" cmpd="sng">
+                      <a:noFill/>
+                      <a:prstDash val="solid"/>
+                    </a:lnTlToBr>
+                    <a:lnBlToTr w="12700" cmpd="sng">
+                      <a:noFill/>
+                      <a:prstDash val="solid"/>
+                    </a:lnBlToTr>
+                    <a:noFill/>
+                  </a:tcPr>
+                </a:tc>
+                <a:tc rowSpan="4">
+                  <a:txBody>
+                    <a:bodyPr/>
+                    <a:lstStyle/>
+                    <a:p>
+                      <a:r>
+                        <a:rPr lang="de-DE" dirty="0">
+                          <a:solidFill>
+                            <a:schemeClr val="tx1"/>
+                          </a:solidFill>
+                        </a:rPr>
+                        <a:t>Entwurf eines Entwicklungsplans</a:t>
+                      </a:r>
+                    </a:p>
+                    <a:p>
+                      <a:r>
+                        <a:rPr lang="de-DE" dirty="0">
+                          <a:solidFill>
+                            <a:schemeClr val="tx1"/>
+                          </a:solidFill>
+                        </a:rPr>
+                        <a:t>Wahl aus Sounds &amp; Musik, Text, UI, Android-Support, Partikel &amp; Animationen, Shader, Datenspeicherung, Metaprogression, Multiplayer, Sensoren, Physik und Kollisionen, prozedurale Generation, komplexere Spielmechaniken</a:t>
                       </a:r>
                     </a:p>
                   </a:txBody>
@@ -4450,23 +5484,24 @@
                 </a:tc>
                 <a:extLst>
                   <a:ext uri="{0D108BD9-81ED-4DB2-BD59-A6C34878D82A}">
-                    <a16:rowId xmlns:a16="http://schemas.microsoft.com/office/drawing/2014/main" val="4008067369"/>
+                    <a16:rowId xmlns:a16="http://schemas.microsoft.com/office/drawing/2014/main" val="2746507518"/>
                   </a:ext>
                 </a:extLst>
               </a:tr>
-              <a:tr h="436563">
+              <a:tr h="370840">
                 <a:tc>
                   <a:txBody>
                     <a:bodyPr/>
                     <a:lstStyle/>
                     <a:p>
+                      <a:pPr algn="r"/>
                       <a:r>
-                        <a:rPr lang="de-DE" u="none">
+                        <a:rPr lang="de-DE" dirty="0">
                           <a:solidFill>
                             <a:schemeClr val="tx1"/>
                           </a:solidFill>
                         </a:rPr>
-                        <a:t>Größer</a:t>
+                        <a:t>8</a:t>
                       </a:r>
                     </a:p>
                   </a:txBody>
@@ -4500,12 +5535,151 @@
                     <a:lstStyle/>
                     <a:p>
                       <a:r>
-                        <a:rPr lang="de-DE" u="none">
+                        <a:rPr lang="de-DE" dirty="0">
                           <a:solidFill>
                             <a:schemeClr val="tx1"/>
                           </a:solidFill>
                         </a:rPr>
-                        <a:t>Shift + &lt;</a:t>
+                        <a:t>Samstag, 14.3.</a:t>
+                      </a:r>
+                    </a:p>
+                  </a:txBody>
+                  <a:tcPr>
+                    <a:lnL w="12700" cmpd="sng">
+                      <a:noFill/>
+                    </a:lnL>
+                    <a:lnR w="12700" cmpd="sng">
+                      <a:noFill/>
+                    </a:lnR>
+                    <a:lnT w="12700" cmpd="sng">
+                      <a:noFill/>
+                    </a:lnT>
+                    <a:lnB w="12700" cmpd="sng">
+                      <a:noFill/>
+                    </a:lnB>
+                    <a:lnTlToBr w="12700" cmpd="sng">
+                      <a:noFill/>
+                      <a:prstDash val="solid"/>
+                    </a:lnTlToBr>
+                    <a:lnBlToTr w="12700" cmpd="sng">
+                      <a:noFill/>
+                      <a:prstDash val="solid"/>
+                    </a:lnBlToTr>
+                    <a:noFill/>
+                  </a:tcPr>
+                </a:tc>
+                <a:tc>
+                  <a:txBody>
+                    <a:bodyPr/>
+                    <a:lstStyle/>
+                    <a:p>
+                      <a:pPr marL="0" marR="0" lvl="0" indent="0" algn="l" defTabSz="914400" rtl="0" eaLnBrk="1" fontAlgn="auto" latinLnBrk="0" hangingPunct="1">
+                        <a:lnSpc>
+                          <a:spcPct val="100000"/>
+                        </a:lnSpc>
+                        <a:spcBef>
+                          <a:spcPts val="0"/>
+                        </a:spcBef>
+                        <a:spcAft>
+                          <a:spcPts val="0"/>
+                        </a:spcAft>
+                        <a:buClrTx/>
+                        <a:buSzTx/>
+                        <a:buFontTx/>
+                        <a:buNone/>
+                        <a:tabLst/>
+                        <a:defRPr/>
+                      </a:pPr>
+                      <a:r>
+                        <a:rPr lang="de-DE" dirty="0">
+                          <a:solidFill>
+                            <a:schemeClr val="tx1"/>
+                          </a:solidFill>
+                        </a:rPr>
+                        <a:t>10 – 14</a:t>
+                      </a:r>
+                    </a:p>
+                  </a:txBody>
+                  <a:tcPr>
+                    <a:lnL w="12700" cmpd="sng">
+                      <a:noFill/>
+                    </a:lnL>
+                    <a:lnR w="12700" cmpd="sng">
+                      <a:noFill/>
+                    </a:lnR>
+                    <a:lnT w="12700" cmpd="sng">
+                      <a:noFill/>
+                    </a:lnT>
+                    <a:lnB w="12700" cmpd="sng">
+                      <a:noFill/>
+                    </a:lnB>
+                    <a:lnTlToBr w="12700" cmpd="sng">
+                      <a:noFill/>
+                      <a:prstDash val="solid"/>
+                    </a:lnTlToBr>
+                    <a:lnBlToTr w="12700" cmpd="sng">
+                      <a:noFill/>
+                      <a:prstDash val="solid"/>
+                    </a:lnBlToTr>
+                    <a:noFill/>
+                  </a:tcPr>
+                </a:tc>
+                <a:tc vMerge="1">
+                  <a:txBody>
+                    <a:bodyPr/>
+                    <a:lstStyle/>
+                    <a:p>
+                      <a:endParaRPr lang="de-DE" dirty="0">
+                        <a:solidFill>
+                          <a:schemeClr val="tx1"/>
+                        </a:solidFill>
+                      </a:endParaRPr>
+                    </a:p>
+                  </a:txBody>
+                  <a:tcPr>
+                    <a:lnL w="12700" cmpd="sng">
+                      <a:noFill/>
+                    </a:lnL>
+                    <a:lnR w="12700" cmpd="sng">
+                      <a:noFill/>
+                    </a:lnR>
+                    <a:lnT w="12700" cmpd="sng">
+                      <a:noFill/>
+                    </a:lnT>
+                    <a:lnB w="12700" cmpd="sng">
+                      <a:noFill/>
+                    </a:lnB>
+                    <a:lnTlToBr w="12700" cmpd="sng">
+                      <a:noFill/>
+                      <a:prstDash val="solid"/>
+                    </a:lnTlToBr>
+                    <a:lnBlToTr w="12700" cmpd="sng">
+                      <a:noFill/>
+                      <a:prstDash val="solid"/>
+                    </a:lnBlToTr>
+                    <a:noFill/>
+                  </a:tcPr>
+                </a:tc>
+                <a:extLst>
+                  <a:ext uri="{0D108BD9-81ED-4DB2-BD59-A6C34878D82A}">
+                    <a16:rowId xmlns:a16="http://schemas.microsoft.com/office/drawing/2014/main" val="447745933"/>
+                  </a:ext>
+                </a:extLst>
+              </a:tr>
+              <a:tr h="370840">
+                <a:tc>
+                  <a:txBody>
+                    <a:bodyPr/>
+                    <a:lstStyle/>
+                    <a:p>
+                      <a:pPr algn="r"/>
+                      <a:r>
+                        <a:rPr lang="de-DE" dirty="0">
+                          <a:solidFill>
+                            <a:schemeClr val="tx1"/>
+                          </a:solidFill>
+                        </a:rPr>
+                        <a:t>9</a:t>
                       </a:r>
                     </a:p>
                   </a:txBody>
@@ -4539,58 +5713,12 @@
                     <a:lstStyle/>
                     <a:p>
                       <a:r>
-                        <a:rPr lang="de-DE" u="none">
+                        <a:rPr lang="de-DE" dirty="0">
                           <a:solidFill>
                             <a:schemeClr val="tx1"/>
                           </a:solidFill>
                         </a:rPr>
-                        <a:t>&gt;</a:t>
-                      </a:r>
-                    </a:p>
-                  </a:txBody>
-                  <a:tcPr>
-                    <a:lnL w="12700" cmpd="sng">
-                      <a:noFill/>
-                    </a:lnL>
-                    <a:lnR w="12700" cmpd="sng">
-                      <a:noFill/>
-                    </a:lnR>
-                    <a:lnT w="12700" cmpd="sng">
-                      <a:noFill/>
-                    </a:lnT>
-                    <a:lnB w="12700" cmpd="sng">
-                      <a:noFill/>
-                    </a:lnB>
-                    <a:lnTlToBr w="12700" cmpd="sng">
-                      <a:noFill/>
-                      <a:prstDash val="solid"/>
-                    </a:lnTlToBr>
-                    <a:lnBlToTr w="12700" cmpd="sng">
-                      <a:noFill/>
-                      <a:prstDash val="solid"/>
-                    </a:lnBlToTr>
-                    <a:noFill/>
-                  </a:tcPr>
-                </a:tc>
-                <a:extLst>
-                  <a:ext uri="{0D108BD9-81ED-4DB2-BD59-A6C34878D82A}">
-                    <a16:rowId xmlns:a16="http://schemas.microsoft.com/office/drawing/2014/main" val="359078954"/>
-                  </a:ext>
-                </a:extLst>
-              </a:tr>
-              <a:tr h="436563">
-                <a:tc>
-                  <a:txBody>
-                    <a:bodyPr/>
-                    <a:lstStyle/>
-                    <a:p>
-                      <a:r>
-                        <a:rPr lang="de-DE" u="none">
-                          <a:solidFill>
-                            <a:schemeClr val="tx1"/>
-                          </a:solidFill>
-                        </a:rPr>
-                        <a:t>Unterstrich</a:t>
+                        <a:t>Freitag, 20.3.</a:t>
                       </a:r>
                     </a:p>
                   </a:txBody>
@@ -4624,12 +5752,95 @@
                     <a:lstStyle/>
                     <a:p>
                       <a:r>
-                        <a:rPr lang="de-DE" u="none">
+                        <a:rPr lang="de-DE" dirty="0">
                           <a:solidFill>
                             <a:schemeClr val="tx1"/>
                           </a:solidFill>
                         </a:rPr>
-                        <a:t>Shift + -</a:t>
+                        <a:t>17 – 20 ?</a:t>
+                      </a:r>
+                    </a:p>
+                  </a:txBody>
+                  <a:tcPr>
+                    <a:lnL w="12700" cmpd="sng">
+                      <a:noFill/>
+                    </a:lnL>
+                    <a:lnR w="12700" cmpd="sng">
+                      <a:noFill/>
+                    </a:lnR>
+                    <a:lnT w="12700" cmpd="sng">
+                      <a:noFill/>
+                    </a:lnT>
+                    <a:lnB w="12700" cmpd="sng">
+                      <a:noFill/>
+                    </a:lnB>
+                    <a:lnTlToBr w="12700" cmpd="sng">
+                      <a:noFill/>
+                      <a:prstDash val="solid"/>
+                    </a:lnTlToBr>
+                    <a:lnBlToTr w="12700" cmpd="sng">
+                      <a:noFill/>
+                      <a:prstDash val="solid"/>
+                    </a:lnBlToTr>
+                    <a:noFill/>
+                  </a:tcPr>
+                </a:tc>
+                <a:tc vMerge="1">
+                  <a:txBody>
+                    <a:bodyPr/>
+                    <a:lstStyle/>
+                    <a:p>
+                      <a:endParaRPr lang="de-DE" dirty="0">
+                        <a:solidFill>
+                          <a:schemeClr val="tx1"/>
+                        </a:solidFill>
+                      </a:endParaRPr>
+                    </a:p>
+                  </a:txBody>
+                  <a:tcPr>
+                    <a:lnL w="12700" cmpd="sng">
+                      <a:noFill/>
+                    </a:lnL>
+                    <a:lnR w="12700" cmpd="sng">
+                      <a:noFill/>
+                    </a:lnR>
+                    <a:lnT w="12700" cmpd="sng">
+                      <a:noFill/>
+                    </a:lnT>
+                    <a:lnB w="12700" cmpd="sng">
+                      <a:noFill/>
+                    </a:lnB>
+                    <a:lnTlToBr w="12700" cmpd="sng">
+                      <a:noFill/>
+                      <a:prstDash val="solid"/>
+                    </a:lnTlToBr>
+                    <a:lnBlToTr w="12700" cmpd="sng">
+                      <a:noFill/>
+                      <a:prstDash val="solid"/>
+                    </a:lnBlToTr>
+                    <a:noFill/>
+                  </a:tcPr>
+                </a:tc>
+                <a:extLst>
+                  <a:ext uri="{0D108BD9-81ED-4DB2-BD59-A6C34878D82A}">
+                    <a16:rowId xmlns:a16="http://schemas.microsoft.com/office/drawing/2014/main" val="1783336438"/>
+                  </a:ext>
+                </a:extLst>
+              </a:tr>
+              <a:tr h="370840">
+                <a:tc>
+                  <a:txBody>
+                    <a:bodyPr/>
+                    <a:lstStyle/>
+                    <a:p>
+                      <a:pPr algn="r"/>
+                      <a:r>
+                        <a:rPr lang="de-DE" dirty="0">
+                          <a:solidFill>
+                            <a:schemeClr val="tx1"/>
+                          </a:solidFill>
+                        </a:rPr>
+                        <a:t>10</a:t>
                       </a:r>
                     </a:p>
                   </a:txBody>
@@ -4663,13 +5874,105 @@
                     <a:lstStyle/>
                     <a:p>
                       <a:r>
-                        <a:rPr lang="de-DE" u="none">
+                        <a:rPr lang="de-DE" dirty="0">
                           <a:solidFill>
                             <a:schemeClr val="tx1"/>
                           </a:solidFill>
                         </a:rPr>
-                        <a:t>_</a:t>
+                        <a:t>Samstag, 21.3.</a:t>
                       </a:r>
+                    </a:p>
+                  </a:txBody>
+                  <a:tcPr>
+                    <a:lnL w="12700" cmpd="sng">
+                      <a:noFill/>
+                    </a:lnL>
+                    <a:lnR w="12700" cmpd="sng">
+                      <a:noFill/>
+                    </a:lnR>
+                    <a:lnT w="12700" cmpd="sng">
+                      <a:noFill/>
+                    </a:lnT>
+                    <a:lnB w="12700" cmpd="sng">
+                      <a:noFill/>
+                    </a:lnB>
+                    <a:lnTlToBr w="12700" cmpd="sng">
+                      <a:noFill/>
+                      <a:prstDash val="solid"/>
+                    </a:lnTlToBr>
+                    <a:lnBlToTr w="12700" cmpd="sng">
+                      <a:noFill/>
+                      <a:prstDash val="solid"/>
+                    </a:lnBlToTr>
+                    <a:noFill/>
+                  </a:tcPr>
+                </a:tc>
+                <a:tc>
+                  <a:txBody>
+                    <a:bodyPr/>
+                    <a:lstStyle/>
+                    <a:p>
+                      <a:pPr marL="0" marR="0" lvl="0" indent="0" algn="l" defTabSz="914400" rtl="0" eaLnBrk="1" fontAlgn="auto" latinLnBrk="0" hangingPunct="1">
+                        <a:lnSpc>
+                          <a:spcPct val="100000"/>
+                        </a:lnSpc>
+                        <a:spcBef>
+                          <a:spcPts val="0"/>
+                        </a:spcBef>
+                        <a:spcAft>
+                          <a:spcPts val="0"/>
+                        </a:spcAft>
+                        <a:buClrTx/>
+                        <a:buSzTx/>
+                        <a:buFontTx/>
+                        <a:buNone/>
+                        <a:tabLst/>
+                        <a:defRPr/>
+                      </a:pPr>
+                      <a:r>
+                        <a:rPr lang="de-DE" dirty="0">
+                          <a:solidFill>
+                            <a:schemeClr val="tx1"/>
+                          </a:solidFill>
+                        </a:rPr>
+                        <a:t>10 – 14</a:t>
+                      </a:r>
+                    </a:p>
+                  </a:txBody>
+                  <a:tcPr>
+                    <a:lnL w="12700" cmpd="sng">
+                      <a:noFill/>
+                    </a:lnL>
+                    <a:lnR w="12700" cmpd="sng">
+                      <a:noFill/>
+                    </a:lnR>
+                    <a:lnT w="12700" cmpd="sng">
+                      <a:noFill/>
+                    </a:lnT>
+                    <a:lnB w="12700" cmpd="sng">
+                      <a:noFill/>
+                    </a:lnB>
+                    <a:lnTlToBr w="12700" cmpd="sng">
+                      <a:noFill/>
+                      <a:prstDash val="solid"/>
+                    </a:lnTlToBr>
+                    <a:lnBlToTr w="12700" cmpd="sng">
+                      <a:noFill/>
+                      <a:prstDash val="solid"/>
+                    </a:lnBlToTr>
+                    <a:noFill/>
+                  </a:tcPr>
+                </a:tc>
+                <a:tc vMerge="1">
+                  <a:txBody>
+                    <a:bodyPr/>
+                    <a:lstStyle/>
+                    <a:p>
+                      <a:endParaRPr lang="de-DE" dirty="0">
+                        <a:solidFill>
+                          <a:schemeClr val="tx1"/>
+                        </a:solidFill>
+                      </a:endParaRPr>
                     </a:p>
                   </a:txBody>
                   <a:tcPr>
@@ -4698,7 +6001,7 @@
                 </a:tc>
                 <a:extLst>
                   <a:ext uri="{0D108BD9-81ED-4DB2-BD59-A6C34878D82A}">
-                    <a16:rowId xmlns:a16="http://schemas.microsoft.com/office/drawing/2014/main" val="2627239541"/>
+                    <a16:rowId xmlns:a16="http://schemas.microsoft.com/office/drawing/2014/main" val="870493087"/>
                   </a:ext>
                 </a:extLst>
               </a:tr>
@@ -4709,7 +6012,7 @@
     </p:spTree>
     <p:extLst>
       <p:ext uri="{BB962C8B-B14F-4D97-AF65-F5344CB8AC3E}">
-        <p14:creationId xmlns:p14="http://schemas.microsoft.com/office/powerpoint/2010/main" val="4173632400"/>
+        <p14:creationId xmlns:p14="http://schemas.microsoft.com/office/powerpoint/2010/main" val="53837270"/>
       </p:ext>
     </p:extLst>
   </p:cSld>
@@ -4719,7 +6022,7 @@
 </p:sld>
 </file>
 
-<file path=ppt/slides/slide3.xml><?xml version="1.0" encoding="utf-8"?>
+<file path=ppt/slides/slide6.xml><?xml version="1.0" encoding="utf-8"?>
 <p:sld xmlns:a="http://schemas.openxmlformats.org/drawingml/2006/main" xmlns:r="http://schemas.openxmlformats.org/officeDocument/2006/relationships" xmlns:p="http://schemas.openxmlformats.org/presentationml/2006/main">
   <p:cSld>
     <p:spTree>
@@ -4738,10 +6041,10 @@
       </p:grpSpPr>
       <p:sp>
         <p:nvSpPr>
-          <p:cNvPr id="2" name="Titel 1">
+          <p:cNvPr id="2" name="Title 1">
             <a:extLst>
               <a:ext uri="{FF2B5EF4-FFF2-40B4-BE49-F238E27FC236}">
-                <a16:creationId xmlns:a16="http://schemas.microsoft.com/office/drawing/2014/main" id="{85E2288E-B7E7-481D-8C02-46CACAC70625}"/>
+                <a16:creationId xmlns:a16="http://schemas.microsoft.com/office/drawing/2014/main" id="{367C06D6-1C95-46F8-8055-08448BD11B9E}"/>
               </a:ext>
             </a:extLst>
           </p:cNvPr>
@@ -4758,1951 +6061,41 @@
           <a:lstStyle/>
           <a:p>
             <a:r>
-              <a:rPr lang="de-DE"/>
-              <a:t>Tastatur-Shortcuts</a:t>
-            </a:r>
-          </a:p>
-        </p:txBody>
-      </p:sp>
-      <p:graphicFrame>
-        <p:nvGraphicFramePr>
-          <p:cNvPr id="5" name="Tabelle 7">
+              <a:rPr lang="de-DE" dirty="0"/>
+              <a:t>Frühstudium</a:t>
+            </a:r>
+          </a:p>
+        </p:txBody>
+      </p:sp>
+      <p:sp>
+        <p:nvSpPr>
+          <p:cNvPr id="3" name="Content Placeholder 2">
             <a:extLst>
               <a:ext uri="{FF2B5EF4-FFF2-40B4-BE49-F238E27FC236}">
-                <a16:creationId xmlns:a16="http://schemas.microsoft.com/office/drawing/2014/main" id="{D75F95FC-911C-4637-9026-3A47ACF0B353}"/>
+                <a16:creationId xmlns:a16="http://schemas.microsoft.com/office/drawing/2014/main" id="{C36264C7-7BBF-49C6-9F95-F804081052B4}"/>
               </a:ext>
             </a:extLst>
           </p:cNvPr>
-          <p:cNvGraphicFramePr>
-            <a:graphicFrameLocks noGrp="1"/>
-          </p:cNvGraphicFramePr>
-          <p:nvPr/>
-        </p:nvGraphicFramePr>
-        <p:xfrm>
-          <a:off x="838200" y="1690688"/>
-          <a:ext cx="10515600" cy="4802193"/>
-        </p:xfrm>
-        <a:graphic>
-          <a:graphicData uri="http://schemas.openxmlformats.org/drawingml/2006/table">
-            <a:tbl>
-              <a:tblPr firstRow="1" bandRow="1">
-                <a:tableStyleId>{5C22544A-7EE6-4342-B048-85BDC9FD1C3A}</a:tableStyleId>
-              </a:tblPr>
-              <a:tblGrid>
-                <a:gridCol w="5044440">
-                  <a:extLst>
-                    <a:ext uri="{9D8B030D-6E8A-4147-A177-3AD203B41FA5}">
-                      <a16:colId xmlns:a16="http://schemas.microsoft.com/office/drawing/2014/main" val="2317810761"/>
-                    </a:ext>
-                  </a:extLst>
-                </a:gridCol>
-                <a:gridCol w="5471160">
-                  <a:extLst>
-                    <a:ext uri="{9D8B030D-6E8A-4147-A177-3AD203B41FA5}">
-                      <a16:colId xmlns:a16="http://schemas.microsoft.com/office/drawing/2014/main" val="3760803087"/>
-                    </a:ext>
-                  </a:extLst>
-                </a:gridCol>
-              </a:tblGrid>
-              <a:tr h="436563">
-                <a:tc>
-                  <a:txBody>
-                    <a:bodyPr/>
-                    <a:lstStyle/>
-                    <a:p>
-                      <a:r>
-                        <a:rPr lang="de-DE" u="none">
-                          <a:solidFill>
-                            <a:schemeClr val="tx1"/>
-                          </a:solidFill>
-                        </a:rPr>
-                        <a:t>Name</a:t>
-                      </a:r>
-                    </a:p>
-                  </a:txBody>
-                  <a:tcPr>
-                    <a:lnL w="12700" cmpd="sng">
-                      <a:noFill/>
-                    </a:lnL>
-                    <a:lnR w="12700" cmpd="sng">
-                      <a:noFill/>
-                    </a:lnR>
-                    <a:lnT w="12700" cmpd="sng">
-                      <a:noFill/>
-                    </a:lnT>
-                    <a:lnB w="38100" cmpd="sng">
-                      <a:noFill/>
-                    </a:lnB>
-                    <a:lnTlToBr w="12700" cmpd="sng">
-                      <a:noFill/>
-                      <a:prstDash val="solid"/>
-                    </a:lnTlToBr>
-                    <a:lnBlToTr w="12700" cmpd="sng">
-                      <a:noFill/>
-                      <a:prstDash val="solid"/>
-                    </a:lnBlToTr>
-                    <a:noFill/>
-                  </a:tcPr>
-                </a:tc>
-                <a:tc>
-                  <a:txBody>
-                    <a:bodyPr/>
-                    <a:lstStyle/>
-                    <a:p>
-                      <a:r>
-                        <a:rPr lang="de-DE" u="none">
-                          <a:solidFill>
-                            <a:schemeClr val="tx1"/>
-                          </a:solidFill>
-                        </a:rPr>
-                        <a:t>Kombination</a:t>
-                      </a:r>
-                    </a:p>
-                  </a:txBody>
-                  <a:tcPr>
-                    <a:lnL w="12700" cmpd="sng">
-                      <a:noFill/>
-                    </a:lnL>
-                    <a:lnR w="12700" cmpd="sng">
-                      <a:noFill/>
-                    </a:lnR>
-                    <a:lnT w="12700" cmpd="sng">
-                      <a:noFill/>
-                    </a:lnT>
-                    <a:lnB w="38100" cmpd="sng">
-                      <a:noFill/>
-                    </a:lnB>
-                    <a:lnTlToBr w="12700" cmpd="sng">
-                      <a:noFill/>
-                      <a:prstDash val="solid"/>
-                    </a:lnTlToBr>
-                    <a:lnBlToTr w="12700" cmpd="sng">
-                      <a:noFill/>
-                      <a:prstDash val="solid"/>
-                    </a:lnBlToTr>
-                    <a:noFill/>
-                  </a:tcPr>
-                </a:tc>
-                <a:extLst>
-                  <a:ext uri="{0D108BD9-81ED-4DB2-BD59-A6C34878D82A}">
-                    <a16:rowId xmlns:a16="http://schemas.microsoft.com/office/drawing/2014/main" val="2371139332"/>
-                  </a:ext>
-                </a:extLst>
-              </a:tr>
-              <a:tr h="436563">
-                <a:tc>
-                  <a:txBody>
-                    <a:bodyPr/>
-                    <a:lstStyle/>
-                    <a:p>
-                      <a:r>
-                        <a:rPr lang="de-DE" u="none">
-                          <a:solidFill>
-                            <a:schemeClr val="tx1"/>
-                          </a:solidFill>
-                        </a:rPr>
-                        <a:t>Element auswählen</a:t>
-                      </a:r>
-                    </a:p>
-                  </a:txBody>
-                  <a:tcPr>
-                    <a:lnL w="12700" cmpd="sng">
-                      <a:noFill/>
-                    </a:lnL>
-                    <a:lnR w="12700" cmpd="sng">
-                      <a:noFill/>
-                    </a:lnR>
-                    <a:lnT w="38100" cmpd="sng">
-                      <a:noFill/>
-                    </a:lnT>
-                    <a:lnB w="12700" cmpd="sng">
-                      <a:noFill/>
-                    </a:lnB>
-                    <a:lnTlToBr w="12700" cmpd="sng">
-                      <a:noFill/>
-                      <a:prstDash val="solid"/>
-                    </a:lnTlToBr>
-                    <a:lnBlToTr w="12700" cmpd="sng">
-                      <a:noFill/>
-                      <a:prstDash val="solid"/>
-                    </a:lnBlToTr>
-                    <a:noFill/>
-                  </a:tcPr>
-                </a:tc>
-                <a:tc>
-                  <a:txBody>
-                    <a:bodyPr/>
-                    <a:lstStyle/>
-                    <a:p>
-                      <a:r>
-                        <a:rPr lang="de-DE" u="none">
-                          <a:solidFill>
-                            <a:schemeClr val="tx1"/>
-                          </a:solidFill>
-                        </a:rPr>
-                        <a:t>Strg + W</a:t>
-                      </a:r>
-                    </a:p>
-                  </a:txBody>
-                  <a:tcPr>
-                    <a:lnL w="12700" cmpd="sng">
-                      <a:noFill/>
-                    </a:lnL>
-                    <a:lnR w="12700" cmpd="sng">
-                      <a:noFill/>
-                    </a:lnR>
-                    <a:lnT w="38100" cmpd="sng">
-                      <a:noFill/>
-                    </a:lnT>
-                    <a:lnB w="12700" cmpd="sng">
-                      <a:noFill/>
-                    </a:lnB>
-                    <a:lnTlToBr w="12700" cmpd="sng">
-                      <a:noFill/>
-                      <a:prstDash val="solid"/>
-                    </a:lnTlToBr>
-                    <a:lnBlToTr w="12700" cmpd="sng">
-                      <a:noFill/>
-                      <a:prstDash val="solid"/>
-                    </a:lnBlToTr>
-                    <a:noFill/>
-                  </a:tcPr>
-                </a:tc>
-                <a:extLst>
-                  <a:ext uri="{0D108BD9-81ED-4DB2-BD59-A6C34878D82A}">
-                    <a16:rowId xmlns:a16="http://schemas.microsoft.com/office/drawing/2014/main" val="3418878006"/>
-                  </a:ext>
-                </a:extLst>
-              </a:tr>
-              <a:tr h="436563">
-                <a:tc>
-                  <a:txBody>
-                    <a:bodyPr/>
-                    <a:lstStyle/>
-                    <a:p>
-                      <a:r>
-                        <a:rPr lang="de-DE" u="none">
-                          <a:solidFill>
-                            <a:schemeClr val="tx1"/>
-                          </a:solidFill>
-                        </a:rPr>
-                        <a:t>Alles auswählen</a:t>
-                      </a:r>
-                    </a:p>
-                  </a:txBody>
-                  <a:tcPr>
-                    <a:lnL w="12700" cmpd="sng">
-                      <a:noFill/>
-                    </a:lnL>
-                    <a:lnR w="12700" cmpd="sng">
-                      <a:noFill/>
-                    </a:lnR>
-                    <a:lnT w="38100" cmpd="sng">
-                      <a:noFill/>
-                    </a:lnT>
-                    <a:lnB w="12700" cmpd="sng">
-                      <a:noFill/>
-                    </a:lnB>
-                    <a:lnTlToBr w="12700" cmpd="sng">
-                      <a:noFill/>
-                      <a:prstDash val="solid"/>
-                    </a:lnTlToBr>
-                    <a:lnBlToTr w="12700" cmpd="sng">
-                      <a:noFill/>
-                      <a:prstDash val="solid"/>
-                    </a:lnBlToTr>
-                    <a:noFill/>
-                  </a:tcPr>
-                </a:tc>
-                <a:tc>
-                  <a:txBody>
-                    <a:bodyPr/>
-                    <a:lstStyle/>
-                    <a:p>
-                      <a:r>
-                        <a:rPr lang="de-DE" u="none">
-                          <a:solidFill>
-                            <a:schemeClr val="tx1"/>
-                          </a:solidFill>
-                        </a:rPr>
-                        <a:t>Strg + A</a:t>
-                      </a:r>
-                    </a:p>
-                  </a:txBody>
-                  <a:tcPr>
-                    <a:lnL w="12700" cmpd="sng">
-                      <a:noFill/>
-                    </a:lnL>
-                    <a:lnR w="12700" cmpd="sng">
-                      <a:noFill/>
-                    </a:lnR>
-                    <a:lnT w="38100" cmpd="sng">
-                      <a:noFill/>
-                    </a:lnT>
-                    <a:lnB w="12700" cmpd="sng">
-                      <a:noFill/>
-                    </a:lnB>
-                    <a:lnTlToBr w="12700" cmpd="sng">
-                      <a:noFill/>
-                      <a:prstDash val="solid"/>
-                    </a:lnTlToBr>
-                    <a:lnBlToTr w="12700" cmpd="sng">
-                      <a:noFill/>
-                      <a:prstDash val="solid"/>
-                    </a:lnBlToTr>
-                    <a:noFill/>
-                  </a:tcPr>
-                </a:tc>
-                <a:extLst>
-                  <a:ext uri="{0D108BD9-81ED-4DB2-BD59-A6C34878D82A}">
-                    <a16:rowId xmlns:a16="http://schemas.microsoft.com/office/drawing/2014/main" val="1137631992"/>
-                  </a:ext>
-                </a:extLst>
-              </a:tr>
-              <a:tr h="436563">
-                <a:tc>
-                  <a:txBody>
-                    <a:bodyPr/>
-                    <a:lstStyle/>
-                    <a:p>
-                      <a:r>
-                        <a:rPr lang="de-DE" u="none">
-                          <a:solidFill>
-                            <a:schemeClr val="tx1"/>
-                          </a:solidFill>
-                        </a:rPr>
-                        <a:t>Kopieren</a:t>
-                      </a:r>
-                    </a:p>
-                  </a:txBody>
-                  <a:tcPr>
-                    <a:lnL w="12700" cmpd="sng">
-                      <a:noFill/>
-                    </a:lnL>
-                    <a:lnR w="12700" cmpd="sng">
-                      <a:noFill/>
-                    </a:lnR>
-                    <a:lnT w="12700" cmpd="sng">
-                      <a:noFill/>
-                    </a:lnT>
-                    <a:lnB w="12700" cmpd="sng">
-                      <a:noFill/>
-                    </a:lnB>
-                    <a:lnTlToBr w="12700" cmpd="sng">
-                      <a:noFill/>
-                      <a:prstDash val="solid"/>
-                    </a:lnTlToBr>
-                    <a:lnBlToTr w="12700" cmpd="sng">
-                      <a:noFill/>
-                      <a:prstDash val="solid"/>
-                    </a:lnBlToTr>
-                    <a:noFill/>
-                  </a:tcPr>
-                </a:tc>
-                <a:tc>
-                  <a:txBody>
-                    <a:bodyPr/>
-                    <a:lstStyle/>
-                    <a:p>
-                      <a:r>
-                        <a:rPr lang="de-DE" u="none">
-                          <a:solidFill>
-                            <a:schemeClr val="tx1"/>
-                          </a:solidFill>
-                        </a:rPr>
-                        <a:t>Strg + C</a:t>
-                      </a:r>
-                    </a:p>
-                  </a:txBody>
-                  <a:tcPr>
-                    <a:lnL w="12700" cmpd="sng">
-                      <a:noFill/>
-                    </a:lnL>
-                    <a:lnR w="12700" cmpd="sng">
-                      <a:noFill/>
-                    </a:lnR>
-                    <a:lnT w="12700" cmpd="sng">
-                      <a:noFill/>
-                    </a:lnT>
-                    <a:lnB w="12700" cmpd="sng">
-                      <a:noFill/>
-                    </a:lnB>
-                    <a:lnTlToBr w="12700" cmpd="sng">
-                      <a:noFill/>
-                      <a:prstDash val="solid"/>
-                    </a:lnTlToBr>
-                    <a:lnBlToTr w="12700" cmpd="sng">
-                      <a:noFill/>
-                      <a:prstDash val="solid"/>
-                    </a:lnBlToTr>
-                    <a:noFill/>
-                  </a:tcPr>
-                </a:tc>
-                <a:extLst>
-                  <a:ext uri="{0D108BD9-81ED-4DB2-BD59-A6C34878D82A}">
-                    <a16:rowId xmlns:a16="http://schemas.microsoft.com/office/drawing/2014/main" val="735349028"/>
-                  </a:ext>
-                </a:extLst>
-              </a:tr>
-              <a:tr h="436563">
-                <a:tc>
-                  <a:txBody>
-                    <a:bodyPr/>
-                    <a:lstStyle/>
-                    <a:p>
-                      <a:r>
-                        <a:rPr lang="de-DE" u="none">
-                          <a:solidFill>
-                            <a:schemeClr val="tx1"/>
-                          </a:solidFill>
-                        </a:rPr>
-                        <a:t>Einfügen</a:t>
-                      </a:r>
-                    </a:p>
-                  </a:txBody>
-                  <a:tcPr>
-                    <a:lnL w="12700" cmpd="sng">
-                      <a:noFill/>
-                    </a:lnL>
-                    <a:lnR w="12700" cmpd="sng">
-                      <a:noFill/>
-                    </a:lnR>
-                    <a:lnT w="12700" cmpd="sng">
-                      <a:noFill/>
-                    </a:lnT>
-                    <a:lnB w="12700" cmpd="sng">
-                      <a:noFill/>
-                    </a:lnB>
-                    <a:lnTlToBr w="12700" cmpd="sng">
-                      <a:noFill/>
-                      <a:prstDash val="solid"/>
-                    </a:lnTlToBr>
-                    <a:lnBlToTr w="12700" cmpd="sng">
-                      <a:noFill/>
-                      <a:prstDash val="solid"/>
-                    </a:lnBlToTr>
-                    <a:noFill/>
-                  </a:tcPr>
-                </a:tc>
-                <a:tc>
-                  <a:txBody>
-                    <a:bodyPr/>
-                    <a:lstStyle/>
-                    <a:p>
-                      <a:r>
-                        <a:rPr lang="de-DE" u="none">
-                          <a:solidFill>
-                            <a:schemeClr val="tx1"/>
-                          </a:solidFill>
-                        </a:rPr>
-                        <a:t>Strg + V</a:t>
-                      </a:r>
-                    </a:p>
-                  </a:txBody>
-                  <a:tcPr>
-                    <a:lnL w="12700" cmpd="sng">
-                      <a:noFill/>
-                    </a:lnL>
-                    <a:lnR w="12700" cmpd="sng">
-                      <a:noFill/>
-                    </a:lnR>
-                    <a:lnT w="12700" cmpd="sng">
-                      <a:noFill/>
-                    </a:lnT>
-                    <a:lnB w="12700" cmpd="sng">
-                      <a:noFill/>
-                    </a:lnB>
-                    <a:lnTlToBr w="12700" cmpd="sng">
-                      <a:noFill/>
-                      <a:prstDash val="solid"/>
-                    </a:lnTlToBr>
-                    <a:lnBlToTr w="12700" cmpd="sng">
-                      <a:noFill/>
-                      <a:prstDash val="solid"/>
-                    </a:lnBlToTr>
-                    <a:noFill/>
-                  </a:tcPr>
-                </a:tc>
-                <a:extLst>
-                  <a:ext uri="{0D108BD9-81ED-4DB2-BD59-A6C34878D82A}">
-                    <a16:rowId xmlns:a16="http://schemas.microsoft.com/office/drawing/2014/main" val="1753339480"/>
-                  </a:ext>
-                </a:extLst>
-              </a:tr>
-              <a:tr h="436563">
-                <a:tc>
-                  <a:txBody>
-                    <a:bodyPr/>
-                    <a:lstStyle/>
-                    <a:p>
-                      <a:r>
-                        <a:rPr lang="de-DE" u="none">
-                          <a:solidFill>
-                            <a:schemeClr val="tx1"/>
-                          </a:solidFill>
-                        </a:rPr>
-                        <a:t>Löschen und Kopieren</a:t>
-                      </a:r>
-                    </a:p>
-                  </a:txBody>
-                  <a:tcPr>
-                    <a:lnL w="12700" cmpd="sng">
-                      <a:noFill/>
-                    </a:lnL>
-                    <a:lnR w="12700" cmpd="sng">
-                      <a:noFill/>
-                    </a:lnR>
-                    <a:lnT w="12700" cmpd="sng">
-                      <a:noFill/>
-                    </a:lnT>
-                    <a:lnB w="12700" cmpd="sng">
-                      <a:noFill/>
-                    </a:lnB>
-                    <a:lnTlToBr w="12700" cmpd="sng">
-                      <a:noFill/>
-                      <a:prstDash val="solid"/>
-                    </a:lnTlToBr>
-                    <a:lnBlToTr w="12700" cmpd="sng">
-                      <a:noFill/>
-                      <a:prstDash val="solid"/>
-                    </a:lnBlToTr>
-                    <a:noFill/>
-                  </a:tcPr>
-                </a:tc>
-                <a:tc>
-                  <a:txBody>
-                    <a:bodyPr/>
-                    <a:lstStyle/>
-                    <a:p>
-                      <a:r>
-                        <a:rPr lang="de-DE" u="none">
-                          <a:solidFill>
-                            <a:schemeClr val="tx1"/>
-                          </a:solidFill>
-                        </a:rPr>
-                        <a:t>Strg + X</a:t>
-                      </a:r>
-                    </a:p>
-                  </a:txBody>
-                  <a:tcPr>
-                    <a:lnL w="12700" cmpd="sng">
-                      <a:noFill/>
-                    </a:lnL>
-                    <a:lnR w="12700" cmpd="sng">
-                      <a:noFill/>
-                    </a:lnR>
-                    <a:lnT w="12700" cmpd="sng">
-                      <a:noFill/>
-                    </a:lnT>
-                    <a:lnB w="12700" cmpd="sng">
-                      <a:noFill/>
-                    </a:lnB>
-                    <a:lnTlToBr w="12700" cmpd="sng">
-                      <a:noFill/>
-                      <a:prstDash val="solid"/>
-                    </a:lnTlToBr>
-                    <a:lnBlToTr w="12700" cmpd="sng">
-                      <a:noFill/>
-                      <a:prstDash val="solid"/>
-                    </a:lnBlToTr>
-                    <a:noFill/>
-                  </a:tcPr>
-                </a:tc>
-                <a:extLst>
-                  <a:ext uri="{0D108BD9-81ED-4DB2-BD59-A6C34878D82A}">
-                    <a16:rowId xmlns:a16="http://schemas.microsoft.com/office/drawing/2014/main" val="4070795586"/>
-                  </a:ext>
-                </a:extLst>
-              </a:tr>
-              <a:tr h="436563">
-                <a:tc>
-                  <a:txBody>
-                    <a:bodyPr/>
-                    <a:lstStyle/>
-                    <a:p>
-                      <a:r>
-                        <a:rPr lang="de-DE" u="none">
-                          <a:solidFill>
-                            <a:schemeClr val="tx1"/>
-                          </a:solidFill>
-                        </a:rPr>
-                        <a:t>Duplizieren</a:t>
-                      </a:r>
-                    </a:p>
-                  </a:txBody>
-                  <a:tcPr>
-                    <a:lnL w="12700" cmpd="sng">
-                      <a:noFill/>
-                    </a:lnL>
-                    <a:lnR w="12700" cmpd="sng">
-                      <a:noFill/>
-                    </a:lnR>
-                    <a:lnT w="12700" cmpd="sng">
-                      <a:noFill/>
-                    </a:lnT>
-                    <a:lnB w="12700" cmpd="sng">
-                      <a:noFill/>
-                    </a:lnB>
-                    <a:lnTlToBr w="12700" cmpd="sng">
-                      <a:noFill/>
-                      <a:prstDash val="solid"/>
-                    </a:lnTlToBr>
-                    <a:lnBlToTr w="12700" cmpd="sng">
-                      <a:noFill/>
-                      <a:prstDash val="solid"/>
-                    </a:lnBlToTr>
-                    <a:noFill/>
-                  </a:tcPr>
-                </a:tc>
-                <a:tc>
-                  <a:txBody>
-                    <a:bodyPr/>
-                    <a:lstStyle/>
-                    <a:p>
-                      <a:r>
-                        <a:rPr lang="de-DE" u="none">
-                          <a:solidFill>
-                            <a:schemeClr val="tx1"/>
-                          </a:solidFill>
-                        </a:rPr>
-                        <a:t>Strg + D</a:t>
-                      </a:r>
-                    </a:p>
-                  </a:txBody>
-                  <a:tcPr>
-                    <a:lnL w="12700" cmpd="sng">
-                      <a:noFill/>
-                    </a:lnL>
-                    <a:lnR w="12700" cmpd="sng">
-                      <a:noFill/>
-                    </a:lnR>
-                    <a:lnT w="12700" cmpd="sng">
-                      <a:noFill/>
-                    </a:lnT>
-                    <a:lnB w="12700" cmpd="sng">
-                      <a:noFill/>
-                    </a:lnB>
-                    <a:lnTlToBr w="12700" cmpd="sng">
-                      <a:noFill/>
-                      <a:prstDash val="solid"/>
-                    </a:lnTlToBr>
-                    <a:lnBlToTr w="12700" cmpd="sng">
-                      <a:noFill/>
-                      <a:prstDash val="solid"/>
-                    </a:lnBlToTr>
-                    <a:noFill/>
-                  </a:tcPr>
-                </a:tc>
-                <a:extLst>
-                  <a:ext uri="{0D108BD9-81ED-4DB2-BD59-A6C34878D82A}">
-                    <a16:rowId xmlns:a16="http://schemas.microsoft.com/office/drawing/2014/main" val="3524437853"/>
-                  </a:ext>
-                </a:extLst>
-              </a:tr>
-              <a:tr h="436563">
-                <a:tc>
-                  <a:txBody>
-                    <a:bodyPr/>
-                    <a:lstStyle/>
-                    <a:p>
-                      <a:r>
-                        <a:rPr lang="de-DE" u="none">
-                          <a:solidFill>
-                            <a:schemeClr val="tx1"/>
-                          </a:solidFill>
-                        </a:rPr>
-                        <a:t>Rückgängig</a:t>
-                      </a:r>
-                    </a:p>
-                  </a:txBody>
-                  <a:tcPr>
-                    <a:lnL w="12700" cmpd="sng">
-                      <a:noFill/>
-                    </a:lnL>
-                    <a:lnR w="12700" cmpd="sng">
-                      <a:noFill/>
-                    </a:lnR>
-                    <a:lnT w="12700" cmpd="sng">
-                      <a:noFill/>
-                    </a:lnT>
-                    <a:lnB w="12700" cmpd="sng">
-                      <a:noFill/>
-                    </a:lnB>
-                    <a:lnTlToBr w="12700" cmpd="sng">
-                      <a:noFill/>
-                      <a:prstDash val="solid"/>
-                    </a:lnTlToBr>
-                    <a:lnBlToTr w="12700" cmpd="sng">
-                      <a:noFill/>
-                      <a:prstDash val="solid"/>
-                    </a:lnBlToTr>
-                    <a:noFill/>
-                  </a:tcPr>
-                </a:tc>
-                <a:tc>
-                  <a:txBody>
-                    <a:bodyPr/>
-                    <a:lstStyle/>
-                    <a:p>
-                      <a:r>
-                        <a:rPr lang="de-DE" u="none">
-                          <a:solidFill>
-                            <a:schemeClr val="tx1"/>
-                          </a:solidFill>
-                        </a:rPr>
-                        <a:t>Strg + Z</a:t>
-                      </a:r>
-                    </a:p>
-                  </a:txBody>
-                  <a:tcPr>
-                    <a:lnL w="12700" cmpd="sng">
-                      <a:noFill/>
-                    </a:lnL>
-                    <a:lnR w="12700" cmpd="sng">
-                      <a:noFill/>
-                    </a:lnR>
-                    <a:lnT w="12700" cmpd="sng">
-                      <a:noFill/>
-                    </a:lnT>
-                    <a:lnB w="12700" cmpd="sng">
-                      <a:noFill/>
-                    </a:lnB>
-                    <a:lnTlToBr w="12700" cmpd="sng">
-                      <a:noFill/>
-                      <a:prstDash val="solid"/>
-                    </a:lnTlToBr>
-                    <a:lnBlToTr w="12700" cmpd="sng">
-                      <a:noFill/>
-                      <a:prstDash val="solid"/>
-                    </a:lnBlToTr>
-                    <a:noFill/>
-                  </a:tcPr>
-                </a:tc>
-                <a:extLst>
-                  <a:ext uri="{0D108BD9-81ED-4DB2-BD59-A6C34878D82A}">
-                    <a16:rowId xmlns:a16="http://schemas.microsoft.com/office/drawing/2014/main" val="2223904026"/>
-                  </a:ext>
-                </a:extLst>
-              </a:tr>
-              <a:tr h="436563">
-                <a:tc>
-                  <a:txBody>
-                    <a:bodyPr/>
-                    <a:lstStyle/>
-                    <a:p>
-                      <a:r>
-                        <a:rPr lang="de-DE" u="none">
-                          <a:solidFill>
-                            <a:schemeClr val="tx1"/>
-                          </a:solidFill>
-                        </a:rPr>
-                        <a:t>Rückrückgängig</a:t>
-                      </a:r>
-                    </a:p>
-                  </a:txBody>
-                  <a:tcPr>
-                    <a:lnL w="12700" cmpd="sng">
-                      <a:noFill/>
-                    </a:lnL>
-                    <a:lnR w="12700" cmpd="sng">
-                      <a:noFill/>
-                    </a:lnR>
-                    <a:lnT w="12700" cmpd="sng">
-                      <a:noFill/>
-                    </a:lnT>
-                    <a:lnB w="12700" cmpd="sng">
-                      <a:noFill/>
-                    </a:lnB>
-                    <a:lnTlToBr w="12700" cmpd="sng">
-                      <a:noFill/>
-                      <a:prstDash val="solid"/>
-                    </a:lnTlToBr>
-                    <a:lnBlToTr w="12700" cmpd="sng">
-                      <a:noFill/>
-                      <a:prstDash val="solid"/>
-                    </a:lnBlToTr>
-                    <a:noFill/>
-                  </a:tcPr>
-                </a:tc>
-                <a:tc>
-                  <a:txBody>
-                    <a:bodyPr/>
-                    <a:lstStyle/>
-                    <a:p>
-                      <a:r>
-                        <a:rPr lang="de-DE" u="none">
-                          <a:solidFill>
-                            <a:schemeClr val="tx1"/>
-                          </a:solidFill>
-                        </a:rPr>
-                        <a:t>Strg + Y</a:t>
-                      </a:r>
-                    </a:p>
-                  </a:txBody>
-                  <a:tcPr>
-                    <a:lnL w="12700" cmpd="sng">
-                      <a:noFill/>
-                    </a:lnL>
-                    <a:lnR w="12700" cmpd="sng">
-                      <a:noFill/>
-                    </a:lnR>
-                    <a:lnT w="12700" cmpd="sng">
-                      <a:noFill/>
-                    </a:lnT>
-                    <a:lnB w="12700" cmpd="sng">
-                      <a:noFill/>
-                    </a:lnB>
-                    <a:lnTlToBr w="12700" cmpd="sng">
-                      <a:noFill/>
-                      <a:prstDash val="solid"/>
-                    </a:lnTlToBr>
-                    <a:lnBlToTr w="12700" cmpd="sng">
-                      <a:noFill/>
-                      <a:prstDash val="solid"/>
-                    </a:lnBlToTr>
-                    <a:noFill/>
-                  </a:tcPr>
-                </a:tc>
-                <a:extLst>
-                  <a:ext uri="{0D108BD9-81ED-4DB2-BD59-A6C34878D82A}">
-                    <a16:rowId xmlns:a16="http://schemas.microsoft.com/office/drawing/2014/main" val="2046807540"/>
-                  </a:ext>
-                </a:extLst>
-              </a:tr>
-              <a:tr h="436563">
-                <a:tc>
-                  <a:txBody>
-                    <a:bodyPr/>
-                    <a:lstStyle/>
-                    <a:p>
-                      <a:r>
-                        <a:rPr lang="de-DE" u="none">
-                          <a:solidFill>
-                            <a:schemeClr val="tx1"/>
-                          </a:solidFill>
-                        </a:rPr>
-                        <a:t>Suchen</a:t>
-                      </a:r>
-                    </a:p>
-                  </a:txBody>
-                  <a:tcPr>
-                    <a:lnL w="12700" cmpd="sng">
-                      <a:noFill/>
-                    </a:lnL>
-                    <a:lnR w="12700" cmpd="sng">
-                      <a:noFill/>
-                    </a:lnR>
-                    <a:lnT w="12700" cmpd="sng">
-                      <a:noFill/>
-                    </a:lnT>
-                    <a:lnB w="12700" cmpd="sng">
-                      <a:noFill/>
-                    </a:lnB>
-                    <a:lnTlToBr w="12700" cmpd="sng">
-                      <a:noFill/>
-                      <a:prstDash val="solid"/>
-                    </a:lnTlToBr>
-                    <a:lnBlToTr w="12700" cmpd="sng">
-                      <a:noFill/>
-                      <a:prstDash val="solid"/>
-                    </a:lnBlToTr>
-                    <a:noFill/>
-                  </a:tcPr>
-                </a:tc>
-                <a:tc>
-                  <a:txBody>
-                    <a:bodyPr/>
-                    <a:lstStyle/>
-                    <a:p>
-                      <a:r>
-                        <a:rPr lang="de-DE" u="none">
-                          <a:solidFill>
-                            <a:schemeClr val="tx1"/>
-                          </a:solidFill>
-                        </a:rPr>
-                        <a:t>Strg + F</a:t>
-                      </a:r>
-                    </a:p>
-                  </a:txBody>
-                  <a:tcPr>
-                    <a:lnL w="12700" cmpd="sng">
-                      <a:noFill/>
-                    </a:lnL>
-                    <a:lnR w="12700" cmpd="sng">
-                      <a:noFill/>
-                    </a:lnR>
-                    <a:lnT w="12700" cmpd="sng">
-                      <a:noFill/>
-                    </a:lnT>
-                    <a:lnB w="12700" cmpd="sng">
-                      <a:noFill/>
-                    </a:lnB>
-                    <a:lnTlToBr w="12700" cmpd="sng">
-                      <a:noFill/>
-                      <a:prstDash val="solid"/>
-                    </a:lnTlToBr>
-                    <a:lnBlToTr w="12700" cmpd="sng">
-                      <a:noFill/>
-                      <a:prstDash val="solid"/>
-                    </a:lnBlToTr>
-                    <a:noFill/>
-                  </a:tcPr>
-                </a:tc>
-                <a:extLst>
-                  <a:ext uri="{0D108BD9-81ED-4DB2-BD59-A6C34878D82A}">
-                    <a16:rowId xmlns:a16="http://schemas.microsoft.com/office/drawing/2014/main" val="4008067369"/>
-                  </a:ext>
-                </a:extLst>
-              </a:tr>
-              <a:tr h="436563">
-                <a:tc>
-                  <a:txBody>
-                    <a:bodyPr/>
-                    <a:lstStyle/>
-                    <a:p>
-                      <a:r>
-                        <a:rPr lang="de-DE" u="none">
-                          <a:solidFill>
-                            <a:schemeClr val="tx1"/>
-                          </a:solidFill>
-                        </a:rPr>
-                        <a:t>Suchen und Ersetzen</a:t>
-                      </a:r>
-                    </a:p>
-                  </a:txBody>
-                  <a:tcPr>
-                    <a:lnL w="12700" cmpd="sng">
-                      <a:noFill/>
-                    </a:lnL>
-                    <a:lnR w="12700" cmpd="sng">
-                      <a:noFill/>
-                    </a:lnR>
-                    <a:lnT w="12700" cmpd="sng">
-                      <a:noFill/>
-                    </a:lnT>
-                    <a:lnB w="12700" cmpd="sng">
-                      <a:noFill/>
-                    </a:lnB>
-                    <a:lnTlToBr w="12700" cmpd="sng">
-                      <a:noFill/>
-                      <a:prstDash val="solid"/>
-                    </a:lnTlToBr>
-                    <a:lnBlToTr w="12700" cmpd="sng">
-                      <a:noFill/>
-                      <a:prstDash val="solid"/>
-                    </a:lnBlToTr>
-                    <a:noFill/>
-                  </a:tcPr>
-                </a:tc>
-                <a:tc>
-                  <a:txBody>
-                    <a:bodyPr/>
-                    <a:lstStyle/>
-                    <a:p>
-                      <a:r>
-                        <a:rPr lang="de-DE" u="none">
-                          <a:solidFill>
-                            <a:schemeClr val="tx1"/>
-                          </a:solidFill>
-                        </a:rPr>
-                        <a:t>Strg + R</a:t>
-                      </a:r>
-                    </a:p>
-                  </a:txBody>
-                  <a:tcPr>
-                    <a:lnL w="12700" cmpd="sng">
-                      <a:noFill/>
-                    </a:lnL>
-                    <a:lnR w="12700" cmpd="sng">
-                      <a:noFill/>
-                    </a:lnR>
-                    <a:lnT w="12700" cmpd="sng">
-                      <a:noFill/>
-                    </a:lnT>
-                    <a:lnB w="12700" cmpd="sng">
-                      <a:noFill/>
-                    </a:lnB>
-                    <a:lnTlToBr w="12700" cmpd="sng">
-                      <a:noFill/>
-                      <a:prstDash val="solid"/>
-                    </a:lnTlToBr>
-                    <a:lnBlToTr w="12700" cmpd="sng">
-                      <a:noFill/>
-                      <a:prstDash val="solid"/>
-                    </a:lnBlToTr>
-                    <a:noFill/>
-                  </a:tcPr>
-                </a:tc>
-                <a:extLst>
-                  <a:ext uri="{0D108BD9-81ED-4DB2-BD59-A6C34878D82A}">
-                    <a16:rowId xmlns:a16="http://schemas.microsoft.com/office/drawing/2014/main" val="359078954"/>
-                  </a:ext>
-                </a:extLst>
-              </a:tr>
-            </a:tbl>
-          </a:graphicData>
-        </a:graphic>
-      </p:graphicFrame>
+          <p:cNvSpPr>
+            <a:spLocks noGrp="1"/>
+          </p:cNvSpPr>
+          <p:nvPr>
+            <p:ph idx="1"/>
+          </p:nvPr>
+        </p:nvSpPr>
+        <p:spPr/>
+        <p:txBody>
+          <a:bodyPr/>
+          <a:lstStyle/>
+          <a:p>
+            <a:endParaRPr lang="de-DE"/>
+          </a:p>
+        </p:txBody>
+      </p:sp>
     </p:spTree>
     <p:extLst>
       <p:ext uri="{BB962C8B-B14F-4D97-AF65-F5344CB8AC3E}">
-        <p14:creationId xmlns:p14="http://schemas.microsoft.com/office/powerpoint/2010/main" val="1211559806"/>
-      </p:ext>
-    </p:extLst>
-  </p:cSld>
-  <p:clrMapOvr>
-    <a:masterClrMapping/>
-  </p:clrMapOvr>
-</p:sld>
-</file>
-
-<file path=ppt/slides/slide4.xml><?xml version="1.0" encoding="utf-8"?>
-<p:sld xmlns:a="http://schemas.openxmlformats.org/drawingml/2006/main" xmlns:r="http://schemas.openxmlformats.org/officeDocument/2006/relationships" xmlns:p="http://schemas.openxmlformats.org/presentationml/2006/main">
-  <p:cSld>
-    <p:spTree>
-      <p:nvGrpSpPr>
-        <p:cNvPr id="1" name=""/>
-        <p:cNvGrpSpPr/>
-        <p:nvPr/>
-      </p:nvGrpSpPr>
-      <p:grpSpPr>
-        <a:xfrm>
-          <a:off x="0" y="0"/>
-          <a:ext cx="0" cy="0"/>
-          <a:chOff x="0" y="0"/>
-          <a:chExt cx="0" cy="0"/>
-        </a:xfrm>
-      </p:grpSpPr>
-      <p:sp>
-        <p:nvSpPr>
-          <p:cNvPr id="2" name="Titel 1">
-            <a:extLst>
-              <a:ext uri="{FF2B5EF4-FFF2-40B4-BE49-F238E27FC236}">
-                <a16:creationId xmlns:a16="http://schemas.microsoft.com/office/drawing/2014/main" id="{85E2288E-B7E7-481D-8C02-46CACAC70625}"/>
-              </a:ext>
-            </a:extLst>
-          </p:cNvPr>
-          <p:cNvSpPr>
-            <a:spLocks noGrp="1"/>
-          </p:cNvSpPr>
-          <p:nvPr>
-            <p:ph type="title"/>
-          </p:nvPr>
-        </p:nvSpPr>
-        <p:spPr/>
-        <p:txBody>
-          <a:bodyPr/>
-          <a:lstStyle/>
-          <a:p>
-            <a:r>
-              <a:rPr lang="de-DE" err="1"/>
-              <a:t>IntelliJ</a:t>
-            </a:r>
-            <a:r>
-              <a:rPr lang="de-DE"/>
-              <a:t>-Shortcuts</a:t>
-            </a:r>
-          </a:p>
-        </p:txBody>
-      </p:sp>
-      <p:graphicFrame>
-        <p:nvGraphicFramePr>
-          <p:cNvPr id="5" name="Tabelle 7">
-            <a:extLst>
-              <a:ext uri="{FF2B5EF4-FFF2-40B4-BE49-F238E27FC236}">
-                <a16:creationId xmlns:a16="http://schemas.microsoft.com/office/drawing/2014/main" id="{D75F95FC-911C-4637-9026-3A47ACF0B353}"/>
-              </a:ext>
-            </a:extLst>
-          </p:cNvPr>
-          <p:cNvGraphicFramePr>
-            <a:graphicFrameLocks noGrp="1"/>
-          </p:cNvGraphicFramePr>
-          <p:nvPr/>
-        </p:nvGraphicFramePr>
-        <p:xfrm>
-          <a:off x="838200" y="1690688"/>
-          <a:ext cx="10515600" cy="4365630"/>
-        </p:xfrm>
-        <a:graphic>
-          <a:graphicData uri="http://schemas.openxmlformats.org/drawingml/2006/table">
-            <a:tbl>
-              <a:tblPr firstRow="1" bandRow="1">
-                <a:tableStyleId>{5C22544A-7EE6-4342-B048-85BDC9FD1C3A}</a:tableStyleId>
-              </a:tblPr>
-              <a:tblGrid>
-                <a:gridCol w="5044440">
-                  <a:extLst>
-                    <a:ext uri="{9D8B030D-6E8A-4147-A177-3AD203B41FA5}">
-                      <a16:colId xmlns:a16="http://schemas.microsoft.com/office/drawing/2014/main" val="2317810761"/>
-                    </a:ext>
-                  </a:extLst>
-                </a:gridCol>
-                <a:gridCol w="5471160">
-                  <a:extLst>
-                    <a:ext uri="{9D8B030D-6E8A-4147-A177-3AD203B41FA5}">
-                      <a16:colId xmlns:a16="http://schemas.microsoft.com/office/drawing/2014/main" val="3760803087"/>
-                    </a:ext>
-                  </a:extLst>
-                </a:gridCol>
-              </a:tblGrid>
-              <a:tr h="436563">
-                <a:tc>
-                  <a:txBody>
-                    <a:bodyPr/>
-                    <a:lstStyle/>
-                    <a:p>
-                      <a:r>
-                        <a:rPr lang="de-DE" u="none">
-                          <a:solidFill>
-                            <a:schemeClr val="tx1"/>
-                          </a:solidFill>
-                        </a:rPr>
-                        <a:t>Name</a:t>
-                      </a:r>
-                    </a:p>
-                  </a:txBody>
-                  <a:tcPr>
-                    <a:lnL w="12700" cmpd="sng">
-                      <a:noFill/>
-                    </a:lnL>
-                    <a:lnR w="12700" cmpd="sng">
-                      <a:noFill/>
-                    </a:lnR>
-                    <a:lnT w="12700" cmpd="sng">
-                      <a:noFill/>
-                    </a:lnT>
-                    <a:lnB w="38100" cmpd="sng">
-                      <a:noFill/>
-                    </a:lnB>
-                    <a:lnTlToBr w="12700" cmpd="sng">
-                      <a:noFill/>
-                      <a:prstDash val="solid"/>
-                    </a:lnTlToBr>
-                    <a:lnBlToTr w="12700" cmpd="sng">
-                      <a:noFill/>
-                      <a:prstDash val="solid"/>
-                    </a:lnBlToTr>
-                    <a:noFill/>
-                  </a:tcPr>
-                </a:tc>
-                <a:tc>
-                  <a:txBody>
-                    <a:bodyPr/>
-                    <a:lstStyle/>
-                    <a:p>
-                      <a:r>
-                        <a:rPr lang="de-DE" u="none">
-                          <a:solidFill>
-                            <a:schemeClr val="tx1"/>
-                          </a:solidFill>
-                        </a:rPr>
-                        <a:t>Kombination</a:t>
-                      </a:r>
-                    </a:p>
-                  </a:txBody>
-                  <a:tcPr>
-                    <a:lnL w="12700" cmpd="sng">
-                      <a:noFill/>
-                    </a:lnL>
-                    <a:lnR w="12700" cmpd="sng">
-                      <a:noFill/>
-                    </a:lnR>
-                    <a:lnT w="12700" cmpd="sng">
-                      <a:noFill/>
-                    </a:lnT>
-                    <a:lnB w="38100" cmpd="sng">
-                      <a:noFill/>
-                    </a:lnB>
-                    <a:lnTlToBr w="12700" cmpd="sng">
-                      <a:noFill/>
-                      <a:prstDash val="solid"/>
-                    </a:lnTlToBr>
-                    <a:lnBlToTr w="12700" cmpd="sng">
-                      <a:noFill/>
-                      <a:prstDash val="solid"/>
-                    </a:lnBlToTr>
-                    <a:noFill/>
-                  </a:tcPr>
-                </a:tc>
-                <a:extLst>
-                  <a:ext uri="{0D108BD9-81ED-4DB2-BD59-A6C34878D82A}">
-                    <a16:rowId xmlns:a16="http://schemas.microsoft.com/office/drawing/2014/main" val="2371139332"/>
-                  </a:ext>
-                </a:extLst>
-              </a:tr>
-              <a:tr h="436563">
-                <a:tc>
-                  <a:txBody>
-                    <a:bodyPr/>
-                    <a:lstStyle/>
-                    <a:p>
-                      <a:r>
-                        <a:rPr lang="de-DE" u="none">
-                          <a:solidFill>
-                            <a:schemeClr val="tx1"/>
-                          </a:solidFill>
-                        </a:rPr>
-                        <a:t>Nach oben / unten scrollen</a:t>
-                      </a:r>
-                    </a:p>
-                  </a:txBody>
-                  <a:tcPr>
-                    <a:lnL w="12700" cmpd="sng">
-                      <a:noFill/>
-                    </a:lnL>
-                    <a:lnR w="12700" cmpd="sng">
-                      <a:noFill/>
-                    </a:lnR>
-                    <a:lnT w="38100" cmpd="sng">
-                      <a:noFill/>
-                    </a:lnT>
-                    <a:lnB w="12700" cmpd="sng">
-                      <a:noFill/>
-                    </a:lnB>
-                    <a:lnTlToBr w="12700" cmpd="sng">
-                      <a:noFill/>
-                      <a:prstDash val="solid"/>
-                    </a:lnTlToBr>
-                    <a:lnBlToTr w="12700" cmpd="sng">
-                      <a:noFill/>
-                      <a:prstDash val="solid"/>
-                    </a:lnBlToTr>
-                    <a:noFill/>
-                  </a:tcPr>
-                </a:tc>
-                <a:tc>
-                  <a:txBody>
-                    <a:bodyPr/>
-                    <a:lstStyle/>
-                    <a:p>
-                      <a:r>
-                        <a:rPr lang="de-DE" u="none">
-                          <a:solidFill>
-                            <a:schemeClr val="tx1"/>
-                          </a:solidFill>
-                        </a:rPr>
-                        <a:t>Strg + ↑↓</a:t>
-                      </a:r>
-                    </a:p>
-                  </a:txBody>
-                  <a:tcPr>
-                    <a:lnL w="12700" cmpd="sng">
-                      <a:noFill/>
-                    </a:lnL>
-                    <a:lnR w="12700" cmpd="sng">
-                      <a:noFill/>
-                    </a:lnR>
-                    <a:lnT w="38100" cmpd="sng">
-                      <a:noFill/>
-                    </a:lnT>
-                    <a:lnB w="12700" cmpd="sng">
-                      <a:noFill/>
-                    </a:lnB>
-                    <a:lnTlToBr w="12700" cmpd="sng">
-                      <a:noFill/>
-                      <a:prstDash val="solid"/>
-                    </a:lnTlToBr>
-                    <a:lnBlToTr w="12700" cmpd="sng">
-                      <a:noFill/>
-                      <a:prstDash val="solid"/>
-                    </a:lnBlToTr>
-                    <a:noFill/>
-                  </a:tcPr>
-                </a:tc>
-                <a:extLst>
-                  <a:ext uri="{0D108BD9-81ED-4DB2-BD59-A6C34878D82A}">
-                    <a16:rowId xmlns:a16="http://schemas.microsoft.com/office/drawing/2014/main" val="3418878006"/>
-                  </a:ext>
-                </a:extLst>
-              </a:tr>
-              <a:tr h="436563">
-                <a:tc>
-                  <a:txBody>
-                    <a:bodyPr/>
-                    <a:lstStyle/>
-                    <a:p>
-                      <a:r>
-                        <a:rPr lang="de-DE" u="none">
-                          <a:solidFill>
-                            <a:schemeClr val="tx1"/>
-                          </a:solidFill>
-                        </a:rPr>
-                        <a:t>Mauszeiger nach links / rechts bewegen</a:t>
-                      </a:r>
-                    </a:p>
-                  </a:txBody>
-                  <a:tcPr>
-                    <a:lnL w="12700" cmpd="sng">
-                      <a:noFill/>
-                    </a:lnL>
-                    <a:lnR w="12700" cmpd="sng">
-                      <a:noFill/>
-                    </a:lnR>
-                    <a:lnT w="38100" cmpd="sng">
-                      <a:noFill/>
-                    </a:lnT>
-                    <a:lnB w="12700" cmpd="sng">
-                      <a:noFill/>
-                    </a:lnB>
-                    <a:lnTlToBr w="12700" cmpd="sng">
-                      <a:noFill/>
-                      <a:prstDash val="solid"/>
-                    </a:lnTlToBr>
-                    <a:lnBlToTr w="12700" cmpd="sng">
-                      <a:noFill/>
-                      <a:prstDash val="solid"/>
-                    </a:lnBlToTr>
-                    <a:noFill/>
-                  </a:tcPr>
-                </a:tc>
-                <a:tc>
-                  <a:txBody>
-                    <a:bodyPr/>
-                    <a:lstStyle/>
-                    <a:p>
-                      <a:r>
-                        <a:rPr lang="de-DE" u="none">
-                          <a:solidFill>
-                            <a:schemeClr val="tx1"/>
-                          </a:solidFill>
-                        </a:rPr>
-                        <a:t>Strg + ←→</a:t>
-                      </a:r>
-                    </a:p>
-                  </a:txBody>
-                  <a:tcPr>
-                    <a:lnL w="12700" cmpd="sng">
-                      <a:noFill/>
-                    </a:lnL>
-                    <a:lnR w="12700" cmpd="sng">
-                      <a:noFill/>
-                    </a:lnR>
-                    <a:lnT w="38100" cmpd="sng">
-                      <a:noFill/>
-                    </a:lnT>
-                    <a:lnB w="12700" cmpd="sng">
-                      <a:noFill/>
-                    </a:lnB>
-                    <a:lnTlToBr w="12700" cmpd="sng">
-                      <a:noFill/>
-                      <a:prstDash val="solid"/>
-                    </a:lnTlToBr>
-                    <a:lnBlToTr w="12700" cmpd="sng">
-                      <a:noFill/>
-                      <a:prstDash val="solid"/>
-                    </a:lnBlToTr>
-                    <a:noFill/>
-                  </a:tcPr>
-                </a:tc>
-                <a:extLst>
-                  <a:ext uri="{0D108BD9-81ED-4DB2-BD59-A6C34878D82A}">
-                    <a16:rowId xmlns:a16="http://schemas.microsoft.com/office/drawing/2014/main" val="1137631992"/>
-                  </a:ext>
-                </a:extLst>
-              </a:tr>
-              <a:tr h="436563">
-                <a:tc>
-                  <a:txBody>
-                    <a:bodyPr/>
-                    <a:lstStyle/>
-                    <a:p>
-                      <a:r>
-                        <a:rPr lang="de-DE" u="none">
-                          <a:solidFill>
-                            <a:schemeClr val="tx1"/>
-                          </a:solidFill>
-                        </a:rPr>
-                        <a:t>Zu Definition / Verwendung springen</a:t>
-                      </a:r>
-                    </a:p>
-                  </a:txBody>
-                  <a:tcPr>
-                    <a:lnL w="12700" cmpd="sng">
-                      <a:noFill/>
-                    </a:lnL>
-                    <a:lnR w="12700" cmpd="sng">
-                      <a:noFill/>
-                    </a:lnR>
-                    <a:lnT w="12700" cmpd="sng">
-                      <a:noFill/>
-                    </a:lnT>
-                    <a:lnB w="12700" cmpd="sng">
-                      <a:noFill/>
-                    </a:lnB>
-                    <a:lnTlToBr w="12700" cmpd="sng">
-                      <a:noFill/>
-                      <a:prstDash val="solid"/>
-                    </a:lnTlToBr>
-                    <a:lnBlToTr w="12700" cmpd="sng">
-                      <a:noFill/>
-                      <a:prstDash val="solid"/>
-                    </a:lnBlToTr>
-                    <a:noFill/>
-                  </a:tcPr>
-                </a:tc>
-                <a:tc>
-                  <a:txBody>
-                    <a:bodyPr/>
-                    <a:lstStyle/>
-                    <a:p>
-                      <a:r>
-                        <a:rPr lang="de-DE" u="none">
-                          <a:solidFill>
-                            <a:schemeClr val="tx1"/>
-                          </a:solidFill>
-                        </a:rPr>
-                        <a:t>Strg + B</a:t>
-                      </a:r>
-                    </a:p>
-                  </a:txBody>
-                  <a:tcPr>
-                    <a:lnL w="12700" cmpd="sng">
-                      <a:noFill/>
-                    </a:lnL>
-                    <a:lnR w="12700" cmpd="sng">
-                      <a:noFill/>
-                    </a:lnR>
-                    <a:lnT w="12700" cmpd="sng">
-                      <a:noFill/>
-                    </a:lnT>
-                    <a:lnB w="12700" cmpd="sng">
-                      <a:noFill/>
-                    </a:lnB>
-                    <a:lnTlToBr w="12700" cmpd="sng">
-                      <a:noFill/>
-                      <a:prstDash val="solid"/>
-                    </a:lnTlToBr>
-                    <a:lnBlToTr w="12700" cmpd="sng">
-                      <a:noFill/>
-                      <a:prstDash val="solid"/>
-                    </a:lnBlToTr>
-                    <a:noFill/>
-                  </a:tcPr>
-                </a:tc>
-                <a:extLst>
-                  <a:ext uri="{0D108BD9-81ED-4DB2-BD59-A6C34878D82A}">
-                    <a16:rowId xmlns:a16="http://schemas.microsoft.com/office/drawing/2014/main" val="735349028"/>
-                  </a:ext>
-                </a:extLst>
-              </a:tr>
-              <a:tr h="436563">
-                <a:tc>
-                  <a:txBody>
-                    <a:bodyPr/>
-                    <a:lstStyle/>
-                    <a:p>
-                      <a:r>
-                        <a:rPr lang="de-DE" u="none">
-                          <a:solidFill>
-                            <a:schemeClr val="tx1"/>
-                          </a:solidFill>
-                        </a:rPr>
-                        <a:t>Methoden überschreiben</a:t>
-                      </a:r>
-                    </a:p>
-                  </a:txBody>
-                  <a:tcPr>
-                    <a:lnL w="12700" cmpd="sng">
-                      <a:noFill/>
-                    </a:lnL>
-                    <a:lnR w="12700" cmpd="sng">
-                      <a:noFill/>
-                    </a:lnR>
-                    <a:lnT w="12700" cmpd="sng">
-                      <a:noFill/>
-                    </a:lnT>
-                    <a:lnB w="12700" cmpd="sng">
-                      <a:noFill/>
-                    </a:lnB>
-                    <a:lnTlToBr w="12700" cmpd="sng">
-                      <a:noFill/>
-                      <a:prstDash val="solid"/>
-                    </a:lnTlToBr>
-                    <a:lnBlToTr w="12700" cmpd="sng">
-                      <a:noFill/>
-                      <a:prstDash val="solid"/>
-                    </a:lnBlToTr>
-                    <a:noFill/>
-                  </a:tcPr>
-                </a:tc>
-                <a:tc>
-                  <a:txBody>
-                    <a:bodyPr/>
-                    <a:lstStyle/>
-                    <a:p>
-                      <a:r>
-                        <a:rPr lang="de-DE" u="none">
-                          <a:solidFill>
-                            <a:schemeClr val="tx1"/>
-                          </a:solidFill>
-                        </a:rPr>
-                        <a:t>Strg + O</a:t>
-                      </a:r>
-                    </a:p>
-                  </a:txBody>
-                  <a:tcPr>
-                    <a:lnL w="12700" cmpd="sng">
-                      <a:noFill/>
-                    </a:lnL>
-                    <a:lnR w="12700" cmpd="sng">
-                      <a:noFill/>
-                    </a:lnR>
-                    <a:lnT w="12700" cmpd="sng">
-                      <a:noFill/>
-                    </a:lnT>
-                    <a:lnB w="12700" cmpd="sng">
-                      <a:noFill/>
-                    </a:lnB>
-                    <a:lnTlToBr w="12700" cmpd="sng">
-                      <a:noFill/>
-                      <a:prstDash val="solid"/>
-                    </a:lnTlToBr>
-                    <a:lnBlToTr w="12700" cmpd="sng">
-                      <a:noFill/>
-                      <a:prstDash val="solid"/>
-                    </a:lnBlToTr>
-                    <a:noFill/>
-                  </a:tcPr>
-                </a:tc>
-                <a:extLst>
-                  <a:ext uri="{0D108BD9-81ED-4DB2-BD59-A6C34878D82A}">
-                    <a16:rowId xmlns:a16="http://schemas.microsoft.com/office/drawing/2014/main" val="1753339480"/>
-                  </a:ext>
-                </a:extLst>
-              </a:tr>
-              <a:tr h="436563">
-                <a:tc>
-                  <a:txBody>
-                    <a:bodyPr/>
-                    <a:lstStyle/>
-                    <a:p>
-                      <a:r>
-                        <a:rPr lang="de-DE" u="none">
-                          <a:solidFill>
-                            <a:schemeClr val="tx1"/>
-                          </a:solidFill>
-                        </a:rPr>
-                        <a:t>Schnell durch das Projekt navigieren</a:t>
-                      </a:r>
-                    </a:p>
-                  </a:txBody>
-                  <a:tcPr>
-                    <a:lnL w="12700" cmpd="sng">
-                      <a:noFill/>
-                    </a:lnL>
-                    <a:lnR w="12700" cmpd="sng">
-                      <a:noFill/>
-                    </a:lnR>
-                    <a:lnT w="12700" cmpd="sng">
-                      <a:noFill/>
-                    </a:lnT>
-                    <a:lnB w="12700" cmpd="sng">
-                      <a:noFill/>
-                    </a:lnB>
-                    <a:lnTlToBr w="12700" cmpd="sng">
-                      <a:noFill/>
-                      <a:prstDash val="solid"/>
-                    </a:lnTlToBr>
-                    <a:lnBlToTr w="12700" cmpd="sng">
-                      <a:noFill/>
-                      <a:prstDash val="solid"/>
-                    </a:lnBlToTr>
-                    <a:noFill/>
-                  </a:tcPr>
-                </a:tc>
-                <a:tc>
-                  <a:txBody>
-                    <a:bodyPr/>
-                    <a:lstStyle/>
-                    <a:p>
-                      <a:r>
-                        <a:rPr lang="de-DE" u="none">
-                          <a:solidFill>
-                            <a:schemeClr val="tx1"/>
-                          </a:solidFill>
-                        </a:rPr>
-                        <a:t>2x Shift</a:t>
-                      </a:r>
-                    </a:p>
-                  </a:txBody>
-                  <a:tcPr>
-                    <a:lnL w="12700" cmpd="sng">
-                      <a:noFill/>
-                    </a:lnL>
-                    <a:lnR w="12700" cmpd="sng">
-                      <a:noFill/>
-                    </a:lnR>
-                    <a:lnT w="12700" cmpd="sng">
-                      <a:noFill/>
-                    </a:lnT>
-                    <a:lnB w="12700" cmpd="sng">
-                      <a:noFill/>
-                    </a:lnB>
-                    <a:lnTlToBr w="12700" cmpd="sng">
-                      <a:noFill/>
-                      <a:prstDash val="solid"/>
-                    </a:lnTlToBr>
-                    <a:lnBlToTr w="12700" cmpd="sng">
-                      <a:noFill/>
-                      <a:prstDash val="solid"/>
-                    </a:lnBlToTr>
-                    <a:noFill/>
-                  </a:tcPr>
-                </a:tc>
-                <a:extLst>
-                  <a:ext uri="{0D108BD9-81ED-4DB2-BD59-A6C34878D82A}">
-                    <a16:rowId xmlns:a16="http://schemas.microsoft.com/office/drawing/2014/main" val="4070795586"/>
-                  </a:ext>
-                </a:extLst>
-              </a:tr>
-              <a:tr h="436563">
-                <a:tc>
-                  <a:txBody>
-                    <a:bodyPr/>
-                    <a:lstStyle/>
-                    <a:p>
-                      <a:r>
-                        <a:rPr lang="de-DE" u="none">
-                          <a:solidFill>
-                            <a:schemeClr val="tx1"/>
-                          </a:solidFill>
-                        </a:rPr>
-                        <a:t>Programm starten</a:t>
-                      </a:r>
-                    </a:p>
-                  </a:txBody>
-                  <a:tcPr>
-                    <a:lnL w="12700" cmpd="sng">
-                      <a:noFill/>
-                    </a:lnL>
-                    <a:lnR w="12700" cmpd="sng">
-                      <a:noFill/>
-                    </a:lnR>
-                    <a:lnT w="12700" cmpd="sng">
-                      <a:noFill/>
-                    </a:lnT>
-                    <a:lnB w="12700" cmpd="sng">
-                      <a:noFill/>
-                    </a:lnB>
-                    <a:lnTlToBr w="12700" cmpd="sng">
-                      <a:noFill/>
-                      <a:prstDash val="solid"/>
-                    </a:lnTlToBr>
-                    <a:lnBlToTr w="12700" cmpd="sng">
-                      <a:noFill/>
-                      <a:prstDash val="solid"/>
-                    </a:lnBlToTr>
-                    <a:noFill/>
-                  </a:tcPr>
-                </a:tc>
-                <a:tc>
-                  <a:txBody>
-                    <a:bodyPr/>
-                    <a:lstStyle/>
-                    <a:p>
-                      <a:r>
-                        <a:rPr lang="de-DE" u="none">
-                          <a:solidFill>
-                            <a:schemeClr val="tx1"/>
-                          </a:solidFill>
-                        </a:rPr>
-                        <a:t>Shift + F10</a:t>
-                      </a:r>
-                    </a:p>
-                  </a:txBody>
-                  <a:tcPr>
-                    <a:lnL w="12700" cmpd="sng">
-                      <a:noFill/>
-                    </a:lnL>
-                    <a:lnR w="12700" cmpd="sng">
-                      <a:noFill/>
-                    </a:lnR>
-                    <a:lnT w="12700" cmpd="sng">
-                      <a:noFill/>
-                    </a:lnT>
-                    <a:lnB w="12700" cmpd="sng">
-                      <a:noFill/>
-                    </a:lnB>
-                    <a:lnTlToBr w="12700" cmpd="sng">
-                      <a:noFill/>
-                      <a:prstDash val="solid"/>
-                    </a:lnTlToBr>
-                    <a:lnBlToTr w="12700" cmpd="sng">
-                      <a:noFill/>
-                      <a:prstDash val="solid"/>
-                    </a:lnBlToTr>
-                    <a:noFill/>
-                  </a:tcPr>
-                </a:tc>
-                <a:extLst>
-                  <a:ext uri="{0D108BD9-81ED-4DB2-BD59-A6C34878D82A}">
-                    <a16:rowId xmlns:a16="http://schemas.microsoft.com/office/drawing/2014/main" val="3524437853"/>
-                  </a:ext>
-                </a:extLst>
-              </a:tr>
-              <a:tr h="436563">
-                <a:tc>
-                  <a:txBody>
-                    <a:bodyPr/>
-                    <a:lstStyle/>
-                    <a:p>
-                      <a:r>
-                        <a:rPr lang="de-DE" u="none">
-                          <a:solidFill>
-                            <a:schemeClr val="tx1"/>
-                          </a:solidFill>
-                        </a:rPr>
-                        <a:t>Code formatieren (schön einrücken)</a:t>
-                      </a:r>
-                    </a:p>
-                  </a:txBody>
-                  <a:tcPr>
-                    <a:lnL w="12700" cmpd="sng">
-                      <a:noFill/>
-                    </a:lnL>
-                    <a:lnR w="12700" cmpd="sng">
-                      <a:noFill/>
-                    </a:lnR>
-                    <a:lnT w="12700" cmpd="sng">
-                      <a:noFill/>
-                    </a:lnT>
-                    <a:lnB w="12700" cmpd="sng">
-                      <a:noFill/>
-                    </a:lnB>
-                    <a:lnTlToBr w="12700" cmpd="sng">
-                      <a:noFill/>
-                      <a:prstDash val="solid"/>
-                    </a:lnTlToBr>
-                    <a:lnBlToTr w="12700" cmpd="sng">
-                      <a:noFill/>
-                      <a:prstDash val="solid"/>
-                    </a:lnBlToTr>
-                    <a:noFill/>
-                  </a:tcPr>
-                </a:tc>
-                <a:tc>
-                  <a:txBody>
-                    <a:bodyPr/>
-                    <a:lstStyle/>
-                    <a:p>
-                      <a:r>
-                        <a:rPr lang="de-DE" u="none">
-                          <a:solidFill>
-                            <a:schemeClr val="tx1"/>
-                          </a:solidFill>
-                        </a:rPr>
-                        <a:t>Strg + Alt + L</a:t>
-                      </a:r>
-                    </a:p>
-                  </a:txBody>
-                  <a:tcPr>
-                    <a:lnL w="12700" cmpd="sng">
-                      <a:noFill/>
-                    </a:lnL>
-                    <a:lnR w="12700" cmpd="sng">
-                      <a:noFill/>
-                    </a:lnR>
-                    <a:lnT w="12700" cmpd="sng">
-                      <a:noFill/>
-                    </a:lnT>
-                    <a:lnB w="12700" cmpd="sng">
-                      <a:noFill/>
-                    </a:lnB>
-                    <a:lnTlToBr w="12700" cmpd="sng">
-                      <a:noFill/>
-                      <a:prstDash val="solid"/>
-                    </a:lnTlToBr>
-                    <a:lnBlToTr w="12700" cmpd="sng">
-                      <a:noFill/>
-                      <a:prstDash val="solid"/>
-                    </a:lnBlToTr>
-                    <a:noFill/>
-                  </a:tcPr>
-                </a:tc>
-                <a:extLst>
-                  <a:ext uri="{0D108BD9-81ED-4DB2-BD59-A6C34878D82A}">
-                    <a16:rowId xmlns:a16="http://schemas.microsoft.com/office/drawing/2014/main" val="2223904026"/>
-                  </a:ext>
-                </a:extLst>
-              </a:tr>
-              <a:tr h="436563">
-                <a:tc>
-                  <a:txBody>
-                    <a:bodyPr/>
-                    <a:lstStyle/>
-                    <a:p>
-                      <a:r>
-                        <a:rPr lang="de-DE" u="none">
-                          <a:solidFill>
-                            <a:schemeClr val="tx1"/>
-                          </a:solidFill>
-                        </a:rPr>
-                        <a:t>Zurück zum vorherigen Mauszeiger</a:t>
-                      </a:r>
-                    </a:p>
-                  </a:txBody>
-                  <a:tcPr>
-                    <a:lnL w="12700" cmpd="sng">
-                      <a:noFill/>
-                    </a:lnL>
-                    <a:lnR w="12700" cmpd="sng">
-                      <a:noFill/>
-                    </a:lnR>
-                    <a:lnT w="12700" cmpd="sng">
-                      <a:noFill/>
-                    </a:lnT>
-                    <a:lnB w="12700" cmpd="sng">
-                      <a:noFill/>
-                    </a:lnB>
-                    <a:lnTlToBr w="12700" cmpd="sng">
-                      <a:noFill/>
-                      <a:prstDash val="solid"/>
-                    </a:lnTlToBr>
-                    <a:lnBlToTr w="12700" cmpd="sng">
-                      <a:noFill/>
-                      <a:prstDash val="solid"/>
-                    </a:lnBlToTr>
-                    <a:noFill/>
-                  </a:tcPr>
-                </a:tc>
-                <a:tc>
-                  <a:txBody>
-                    <a:bodyPr/>
-                    <a:lstStyle/>
-                    <a:p>
-                      <a:r>
-                        <a:rPr lang="de-DE" u="none">
-                          <a:solidFill>
-                            <a:schemeClr val="tx1"/>
-                          </a:solidFill>
-                        </a:rPr>
-                        <a:t>Strg + Alt + ←→</a:t>
-                      </a:r>
-                    </a:p>
-                  </a:txBody>
-                  <a:tcPr>
-                    <a:lnL w="12700" cmpd="sng">
-                      <a:noFill/>
-                    </a:lnL>
-                    <a:lnR w="12700" cmpd="sng">
-                      <a:noFill/>
-                    </a:lnR>
-                    <a:lnT w="12700" cmpd="sng">
-                      <a:noFill/>
-                    </a:lnT>
-                    <a:lnB w="12700" cmpd="sng">
-                      <a:noFill/>
-                    </a:lnB>
-                    <a:lnTlToBr w="12700" cmpd="sng">
-                      <a:noFill/>
-                      <a:prstDash val="solid"/>
-                    </a:lnTlToBr>
-                    <a:lnBlToTr w="12700" cmpd="sng">
-                      <a:noFill/>
-                      <a:prstDash val="solid"/>
-                    </a:lnBlToTr>
-                    <a:noFill/>
-                  </a:tcPr>
-                </a:tc>
-                <a:extLst>
-                  <a:ext uri="{0D108BD9-81ED-4DB2-BD59-A6C34878D82A}">
-                    <a16:rowId xmlns:a16="http://schemas.microsoft.com/office/drawing/2014/main" val="2046807540"/>
-                  </a:ext>
-                </a:extLst>
-              </a:tr>
-              <a:tr h="436563">
-                <a:tc>
-                  <a:txBody>
-                    <a:bodyPr/>
-                    <a:lstStyle/>
-                    <a:p>
-                      <a:r>
-                        <a:rPr lang="de-DE" u="none">
-                          <a:solidFill>
-                            <a:schemeClr val="tx1"/>
-                          </a:solidFill>
-                        </a:rPr>
-                        <a:t>Zu Mauszeiger springen</a:t>
-                      </a:r>
-                    </a:p>
-                  </a:txBody>
-                  <a:tcPr>
-                    <a:lnL w="12700" cmpd="sng">
-                      <a:noFill/>
-                    </a:lnL>
-                    <a:lnR w="12700" cmpd="sng">
-                      <a:noFill/>
-                    </a:lnR>
-                    <a:lnT w="12700" cmpd="sng">
-                      <a:noFill/>
-                    </a:lnT>
-                    <a:lnB w="12700" cmpd="sng">
-                      <a:noFill/>
-                    </a:lnB>
-                    <a:lnTlToBr w="12700" cmpd="sng">
-                      <a:noFill/>
-                      <a:prstDash val="solid"/>
-                    </a:lnTlToBr>
-                    <a:lnBlToTr w="12700" cmpd="sng">
-                      <a:noFill/>
-                      <a:prstDash val="solid"/>
-                    </a:lnBlToTr>
-                    <a:noFill/>
-                  </a:tcPr>
-                </a:tc>
-                <a:tc>
-                  <a:txBody>
-                    <a:bodyPr/>
-                    <a:lstStyle/>
-                    <a:p>
-                      <a:r>
-                        <a:rPr lang="de-DE" u="none">
-                          <a:solidFill>
-                            <a:schemeClr val="tx1"/>
-                          </a:solidFill>
-                        </a:rPr>
-                        <a:t>Strg + M</a:t>
-                      </a:r>
-                    </a:p>
-                  </a:txBody>
-                  <a:tcPr>
-                    <a:lnL w="12700" cmpd="sng">
-                      <a:noFill/>
-                    </a:lnL>
-                    <a:lnR w="12700" cmpd="sng">
-                      <a:noFill/>
-                    </a:lnR>
-                    <a:lnT w="12700" cmpd="sng">
-                      <a:noFill/>
-                    </a:lnT>
-                    <a:lnB w="12700" cmpd="sng">
-                      <a:noFill/>
-                    </a:lnB>
-                    <a:lnTlToBr w="12700" cmpd="sng">
-                      <a:noFill/>
-                      <a:prstDash val="solid"/>
-                    </a:lnTlToBr>
-                    <a:lnBlToTr w="12700" cmpd="sng">
-                      <a:noFill/>
-                      <a:prstDash val="solid"/>
-                    </a:lnBlToTr>
-                    <a:noFill/>
-                  </a:tcPr>
-                </a:tc>
-                <a:extLst>
-                  <a:ext uri="{0D108BD9-81ED-4DB2-BD59-A6C34878D82A}">
-                    <a16:rowId xmlns:a16="http://schemas.microsoft.com/office/drawing/2014/main" val="673940612"/>
-                  </a:ext>
-                </a:extLst>
-              </a:tr>
-            </a:tbl>
-          </a:graphicData>
-        </a:graphic>
-      </p:graphicFrame>
-    </p:spTree>
-    <p:extLst>
-      <p:ext uri="{BB962C8B-B14F-4D97-AF65-F5344CB8AC3E}">
-        <p14:creationId xmlns:p14="http://schemas.microsoft.com/office/powerpoint/2010/main" val="3199209318"/>
+        <p14:creationId xmlns:p14="http://schemas.microsoft.com/office/powerpoint/2010/main" val="2910027476"/>
       </p:ext>
     </p:extLst>
   </p:cSld>
@@ -6715,12 +6108,12 @@
 <file path=ppt/theme/theme1.xml><?xml version="1.0" encoding="utf-8"?>
 <a:theme xmlns:a="http://schemas.openxmlformats.org/drawingml/2006/main" name="Office">
   <a:themeElements>
-    <a:clrScheme name="Office">
+    <a:clrScheme name="Custom 4">
       <a:dk1>
         <a:sysClr val="windowText" lastClr="000000"/>
       </a:dk1>
       <a:lt1>
-        <a:sysClr val="window" lastClr="FFFFFF"/>
+        <a:srgbClr val="F2F5FA"/>
       </a:lt1>
       <a:dk2>
         <a:srgbClr val="44546A"/>

</xml_diff>